<commit_message>
adding get ready slide
</commit_message>
<xml_diff>
--- a/Unix3/Ada_in_depth.pptx
+++ b/Unix3/Ada_in_depth.pptx
@@ -5,48 +5,49 @@
     <p:sldMasterId id="2147483648" r:id="rId1"/>
   </p:sldMasterIdLst>
   <p:notesMasterIdLst>
-    <p:notesMasterId r:id="rId41"/>
+    <p:notesMasterId r:id="rId42"/>
   </p:notesMasterIdLst>
   <p:sldIdLst>
     <p:sldId id="256" r:id="rId2"/>
-    <p:sldId id="309" r:id="rId3"/>
-    <p:sldId id="275" r:id="rId4"/>
-    <p:sldId id="277" r:id="rId5"/>
-    <p:sldId id="261" r:id="rId6"/>
-    <p:sldId id="281" r:id="rId7"/>
-    <p:sldId id="291" r:id="rId8"/>
-    <p:sldId id="282" r:id="rId9"/>
-    <p:sldId id="283" r:id="rId10"/>
-    <p:sldId id="284" r:id="rId11"/>
-    <p:sldId id="285" r:id="rId12"/>
-    <p:sldId id="286" r:id="rId13"/>
-    <p:sldId id="287" r:id="rId14"/>
-    <p:sldId id="288" r:id="rId15"/>
-    <p:sldId id="289" r:id="rId16"/>
-    <p:sldId id="290" r:id="rId17"/>
-    <p:sldId id="292" r:id="rId18"/>
-    <p:sldId id="303" r:id="rId19"/>
-    <p:sldId id="257" r:id="rId20"/>
-    <p:sldId id="293" r:id="rId21"/>
-    <p:sldId id="258" r:id="rId22"/>
-    <p:sldId id="295" r:id="rId23"/>
-    <p:sldId id="296" r:id="rId24"/>
-    <p:sldId id="297" r:id="rId25"/>
-    <p:sldId id="298" r:id="rId26"/>
-    <p:sldId id="304" r:id="rId27"/>
-    <p:sldId id="260" r:id="rId28"/>
-    <p:sldId id="310" r:id="rId29"/>
-    <p:sldId id="262" r:id="rId30"/>
-    <p:sldId id="263" r:id="rId31"/>
-    <p:sldId id="312" r:id="rId32"/>
-    <p:sldId id="305" r:id="rId33"/>
-    <p:sldId id="306" r:id="rId34"/>
-    <p:sldId id="264" r:id="rId35"/>
-    <p:sldId id="307" r:id="rId36"/>
-    <p:sldId id="265" r:id="rId37"/>
-    <p:sldId id="302" r:id="rId38"/>
-    <p:sldId id="259" r:id="rId39"/>
-    <p:sldId id="294" r:id="rId40"/>
+    <p:sldId id="313" r:id="rId3"/>
+    <p:sldId id="309" r:id="rId4"/>
+    <p:sldId id="275" r:id="rId5"/>
+    <p:sldId id="277" r:id="rId6"/>
+    <p:sldId id="261" r:id="rId7"/>
+    <p:sldId id="281" r:id="rId8"/>
+    <p:sldId id="291" r:id="rId9"/>
+    <p:sldId id="282" r:id="rId10"/>
+    <p:sldId id="283" r:id="rId11"/>
+    <p:sldId id="284" r:id="rId12"/>
+    <p:sldId id="285" r:id="rId13"/>
+    <p:sldId id="286" r:id="rId14"/>
+    <p:sldId id="287" r:id="rId15"/>
+    <p:sldId id="288" r:id="rId16"/>
+    <p:sldId id="289" r:id="rId17"/>
+    <p:sldId id="290" r:id="rId18"/>
+    <p:sldId id="292" r:id="rId19"/>
+    <p:sldId id="303" r:id="rId20"/>
+    <p:sldId id="257" r:id="rId21"/>
+    <p:sldId id="293" r:id="rId22"/>
+    <p:sldId id="258" r:id="rId23"/>
+    <p:sldId id="295" r:id="rId24"/>
+    <p:sldId id="296" r:id="rId25"/>
+    <p:sldId id="297" r:id="rId26"/>
+    <p:sldId id="298" r:id="rId27"/>
+    <p:sldId id="304" r:id="rId28"/>
+    <p:sldId id="260" r:id="rId29"/>
+    <p:sldId id="310" r:id="rId30"/>
+    <p:sldId id="262" r:id="rId31"/>
+    <p:sldId id="263" r:id="rId32"/>
+    <p:sldId id="312" r:id="rId33"/>
+    <p:sldId id="305" r:id="rId34"/>
+    <p:sldId id="306" r:id="rId35"/>
+    <p:sldId id="264" r:id="rId36"/>
+    <p:sldId id="307" r:id="rId37"/>
+    <p:sldId id="265" r:id="rId38"/>
+    <p:sldId id="302" r:id="rId39"/>
+    <p:sldId id="259" r:id="rId40"/>
+    <p:sldId id="294" r:id="rId41"/>
   </p:sldIdLst>
   <p:sldSz cx="12192000" cy="6858000"/>
   <p:notesSz cx="6858000" cy="9144000"/>
@@ -151,6 +152,7 @@
         <p14:section name="Logging in" id="{286D0511-4436-324B-AFCB-CBCBCB46791C}">
           <p14:sldIdLst>
             <p14:sldId id="256"/>
+            <p14:sldId id="313"/>
             <p14:sldId id="309"/>
             <p14:sldId id="275"/>
             <p14:sldId id="277"/>
@@ -220,12 +222,20 @@
 </p:presentation>
 </file>
 
+<file path=ppt/revisionInfo.xml><?xml version="1.0" encoding="utf-8"?>
+<p1510:revInfo xmlns:a="http://schemas.openxmlformats.org/drawingml/2006/main" xmlns:r="http://schemas.openxmlformats.org/officeDocument/2006/relationships" xmlns:p1510="http://schemas.microsoft.com/office/powerpoint/2015/10/main">
+  <p1510:revLst>
+    <p1510:client id="{F3175514-0CBB-B448-ADB7-D83A9CE824B9}" v="2" dt="2025-10-09T09:20:39.016"/>
+  </p1510:revLst>
+</p1510:revInfo>
+</file>
+
 <file path=ppt/changesInfos/changesInfo1.xml><?xml version="1.0" encoding="utf-8"?>
 <pc:chgInfo xmlns:a="http://schemas.openxmlformats.org/drawingml/2006/main" xmlns:r="http://schemas.openxmlformats.org/officeDocument/2006/relationships" xmlns:ac="http://schemas.microsoft.com/office/drawing/2013/main/command" xmlns:pc="http://schemas.microsoft.com/office/powerpoint/2013/main/command">
   <pc:docChgLst>
     <pc:chgData name="Laura Dean (staff)" userId="d8747312-ac52-4b4d-9ae4-1e15c3e0516b" providerId="ADAL" clId="{0A5FCBA3-0436-57F2-9A98-325546E6318B}"/>
-    <pc:docChg chg="delSld modSld sldOrd delSection modSection">
-      <pc:chgData name="Laura Dean (staff)" userId="d8747312-ac52-4b4d-9ae4-1e15c3e0516b" providerId="ADAL" clId="{0A5FCBA3-0436-57F2-9A98-325546E6318B}" dt="2025-10-09T08:52:45.235" v="13" actId="20578"/>
+    <pc:docChg chg="custSel addSld delSld modSld sldOrd delSection modSection">
+      <pc:chgData name="Laura Dean (staff)" userId="d8747312-ac52-4b4d-9ae4-1e15c3e0516b" providerId="ADAL" clId="{0A5FCBA3-0436-57F2-9A98-325546E6318B}" dt="2025-10-09T09:21:14.100" v="114" actId="14100"/>
       <pc:docMkLst>
         <pc:docMk/>
       </pc:docMkLst>
@@ -293,6 +303,29 @@
           </ac:spMkLst>
         </pc:spChg>
       </pc:sldChg>
+      <pc:sldChg chg="modSp add mod">
+        <pc:chgData name="Laura Dean (staff)" userId="d8747312-ac52-4b4d-9ae4-1e15c3e0516b" providerId="ADAL" clId="{0A5FCBA3-0436-57F2-9A98-325546E6318B}" dt="2025-10-09T09:21:14.100" v="114" actId="14100"/>
+        <pc:sldMkLst>
+          <pc:docMk/>
+          <pc:sldMk cId="1517161138" sldId="313"/>
+        </pc:sldMkLst>
+        <pc:spChg chg="mod">
+          <ac:chgData name="Laura Dean (staff)" userId="d8747312-ac52-4b4d-9ae4-1e15c3e0516b" providerId="ADAL" clId="{0A5FCBA3-0436-57F2-9A98-325546E6318B}" dt="2025-10-09T09:20:58.066" v="111" actId="1076"/>
+          <ac:spMkLst>
+            <pc:docMk/>
+            <pc:sldMk cId="1517161138" sldId="313"/>
+            <ac:spMk id="2" creationId="{C710A4FC-3C1C-5FCF-694F-F3286F802636}"/>
+          </ac:spMkLst>
+        </pc:spChg>
+        <pc:spChg chg="mod">
+          <ac:chgData name="Laura Dean (staff)" userId="d8747312-ac52-4b4d-9ae4-1e15c3e0516b" providerId="ADAL" clId="{0A5FCBA3-0436-57F2-9A98-325546E6318B}" dt="2025-10-09T09:21:14.100" v="114" actId="14100"/>
+          <ac:spMkLst>
+            <pc:docMk/>
+            <pc:sldMk cId="1517161138" sldId="313"/>
+            <ac:spMk id="5" creationId="{4B3F8C97-50B0-0ED6-7C76-A1CCC5154D72}"/>
+          </ac:spMkLst>
+        </pc:spChg>
+      </pc:sldChg>
       <pc:sldChg chg="del">
         <pc:chgData name="Laura Dean (staff)" userId="d8747312-ac52-4b4d-9ae4-1e15c3e0516b" providerId="ADAL" clId="{0A5FCBA3-0436-57F2-9A98-325546E6318B}" dt="2025-10-06T10:18:45.806" v="5" actId="2696"/>
         <pc:sldMkLst>
@@ -408,7 +441,7 @@
           <a:p>
             <a:fld id="{3A946387-3DE6-A047-9929-F7D6E7284C24}" type="datetimeFigureOut">
               <a:rPr lang="en-US" smtClean="0"/>
-              <a:t>10/6/25</a:t>
+              <a:t>10/9/25</a:t>
             </a:fld>
             <a:endParaRPr lang="en-US"/>
           </a:p>
@@ -768,6 +801,114 @@
         <p:cNvPr id="1" name="">
           <a:extLst>
             <a:ext uri="{FF2B5EF4-FFF2-40B4-BE49-F238E27FC236}">
+              <a16:creationId xmlns:a16="http://schemas.microsoft.com/office/drawing/2014/main" id="{79017030-0C6A-30FA-9FD9-DF51D0CB2F57}"/>
+            </a:ext>
+          </a:extLst>
+        </p:cNvPr>
+        <p:cNvGrpSpPr/>
+        <p:nvPr/>
+      </p:nvGrpSpPr>
+      <p:grpSpPr>
+        <a:xfrm>
+          <a:off x="0" y="0"/>
+          <a:ext cx="0" cy="0"/>
+          <a:chOff x="0" y="0"/>
+          <a:chExt cx="0" cy="0"/>
+        </a:xfrm>
+      </p:grpSpPr>
+      <p:sp>
+        <p:nvSpPr>
+          <p:cNvPr id="2" name="Slide Image Placeholder 1">
+            <a:extLst>
+              <a:ext uri="{FF2B5EF4-FFF2-40B4-BE49-F238E27FC236}">
+                <a16:creationId xmlns:a16="http://schemas.microsoft.com/office/drawing/2014/main" id="{6318BE7F-97A1-16CB-4A8B-2FA9481F1F64}"/>
+              </a:ext>
+            </a:extLst>
+          </p:cNvPr>
+          <p:cNvSpPr>
+            <a:spLocks noGrp="1" noRot="1" noChangeAspect="1"/>
+          </p:cNvSpPr>
+          <p:nvPr>
+            <p:ph type="sldImg"/>
+          </p:nvPr>
+        </p:nvSpPr>
+        <p:spPr/>
+      </p:sp>
+      <p:sp>
+        <p:nvSpPr>
+          <p:cNvPr id="3" name="Notes Placeholder 2">
+            <a:extLst>
+              <a:ext uri="{FF2B5EF4-FFF2-40B4-BE49-F238E27FC236}">
+                <a16:creationId xmlns:a16="http://schemas.microsoft.com/office/drawing/2014/main" id="{FE333B5C-883A-C796-A8F4-7B7BC029622B}"/>
+              </a:ext>
+            </a:extLst>
+          </p:cNvPr>
+          <p:cNvSpPr>
+            <a:spLocks noGrp="1"/>
+          </p:cNvSpPr>
+          <p:nvPr>
+            <p:ph type="body" idx="1"/>
+          </p:nvPr>
+        </p:nvSpPr>
+        <p:spPr/>
+        <p:txBody>
+          <a:bodyPr/>
+          <a:lstStyle/>
+          <a:p>
+            <a:endParaRPr lang="en-US" dirty="0"/>
+          </a:p>
+        </p:txBody>
+      </p:sp>
+      <p:sp>
+        <p:nvSpPr>
+          <p:cNvPr id="4" name="Slide Number Placeholder 3">
+            <a:extLst>
+              <a:ext uri="{FF2B5EF4-FFF2-40B4-BE49-F238E27FC236}">
+                <a16:creationId xmlns:a16="http://schemas.microsoft.com/office/drawing/2014/main" id="{96FB3AE2-B72C-BC08-0F6B-75CACE072B0D}"/>
+              </a:ext>
+            </a:extLst>
+          </p:cNvPr>
+          <p:cNvSpPr>
+            <a:spLocks noGrp="1"/>
+          </p:cNvSpPr>
+          <p:nvPr>
+            <p:ph type="sldNum" sz="quarter" idx="5"/>
+          </p:nvPr>
+        </p:nvSpPr>
+        <p:spPr/>
+        <p:txBody>
+          <a:bodyPr/>
+          <a:lstStyle/>
+          <a:p>
+            <a:fld id="{AC44E78C-583C-4D47-AA52-A4329031AEEE}" type="slidenum">
+              <a:rPr lang="en-US" smtClean="0"/>
+              <a:t>10</a:t>
+            </a:fld>
+            <a:endParaRPr lang="en-US"/>
+          </a:p>
+        </p:txBody>
+      </p:sp>
+    </p:spTree>
+    <p:extLst>
+      <p:ext uri="{BB962C8B-B14F-4D97-AF65-F5344CB8AC3E}">
+        <p14:creationId xmlns:p14="http://schemas.microsoft.com/office/powerpoint/2010/main" val="370350663"/>
+      </p:ext>
+    </p:extLst>
+  </p:cSld>
+  <p:clrMapOvr>
+    <a:masterClrMapping/>
+  </p:clrMapOvr>
+</p:notes>
+</file>
+
+<file path=ppt/notesSlides/notesSlide11.xml><?xml version="1.0" encoding="utf-8"?>
+<p:notes xmlns:a="http://schemas.openxmlformats.org/drawingml/2006/main" xmlns:r="http://schemas.openxmlformats.org/officeDocument/2006/relationships" xmlns:p="http://schemas.openxmlformats.org/presentationml/2006/main">
+  <p:cSld>
+    <p:spTree>
+      <p:nvGrpSpPr>
+        <p:cNvPr id="1" name="">
+          <a:extLst>
+            <a:ext uri="{FF2B5EF4-FFF2-40B4-BE49-F238E27FC236}">
               <a16:creationId xmlns:a16="http://schemas.microsoft.com/office/drawing/2014/main" id="{7A765AFA-C0D7-DFE1-0429-9574B504D8E6}"/>
             </a:ext>
           </a:extLst>
@@ -849,7 +990,7 @@
           <a:p>
             <a:fld id="{AC44E78C-583C-4D47-AA52-A4329031AEEE}" type="slidenum">
               <a:rPr lang="en-US" smtClean="0"/>
-              <a:t>10</a:t>
+              <a:t>11</a:t>
             </a:fld>
             <a:endParaRPr lang="en-US"/>
           </a:p>
@@ -868,7 +1009,7 @@
 </p:notes>
 </file>
 
-<file path=ppt/notesSlides/notesSlide11.xml><?xml version="1.0" encoding="utf-8"?>
+<file path=ppt/notesSlides/notesSlide12.xml><?xml version="1.0" encoding="utf-8"?>
 <p:notes xmlns:a="http://schemas.openxmlformats.org/drawingml/2006/main" xmlns:r="http://schemas.openxmlformats.org/officeDocument/2006/relationships" xmlns:p="http://schemas.openxmlformats.org/presentationml/2006/main">
   <p:cSld>
     <p:spTree>
@@ -957,7 +1098,7 @@
           <a:p>
             <a:fld id="{AC44E78C-583C-4D47-AA52-A4329031AEEE}" type="slidenum">
               <a:rPr lang="en-US" smtClean="0"/>
-              <a:t>11</a:t>
+              <a:t>12</a:t>
             </a:fld>
             <a:endParaRPr lang="en-US"/>
           </a:p>
@@ -976,7 +1117,7 @@
 </p:notes>
 </file>
 
-<file path=ppt/notesSlides/notesSlide12.xml><?xml version="1.0" encoding="utf-8"?>
+<file path=ppt/notesSlides/notesSlide13.xml><?xml version="1.0" encoding="utf-8"?>
 <p:notes xmlns:a="http://schemas.openxmlformats.org/drawingml/2006/main" xmlns:r="http://schemas.openxmlformats.org/officeDocument/2006/relationships" xmlns:p="http://schemas.openxmlformats.org/presentationml/2006/main">
   <p:cSld>
     <p:spTree>
@@ -1065,7 +1206,7 @@
           <a:p>
             <a:fld id="{AC44E78C-583C-4D47-AA52-A4329031AEEE}" type="slidenum">
               <a:rPr lang="en-US" smtClean="0"/>
-              <a:t>12</a:t>
+              <a:t>13</a:t>
             </a:fld>
             <a:endParaRPr lang="en-US"/>
           </a:p>
@@ -1084,7 +1225,7 @@
 </p:notes>
 </file>
 
-<file path=ppt/notesSlides/notesSlide13.xml><?xml version="1.0" encoding="utf-8"?>
+<file path=ppt/notesSlides/notesSlide14.xml><?xml version="1.0" encoding="utf-8"?>
 <p:notes xmlns:a="http://schemas.openxmlformats.org/drawingml/2006/main" xmlns:r="http://schemas.openxmlformats.org/officeDocument/2006/relationships" xmlns:p="http://schemas.openxmlformats.org/presentationml/2006/main">
   <p:cSld>
     <p:spTree>
@@ -1173,7 +1314,7 @@
           <a:p>
             <a:fld id="{AC44E78C-583C-4D47-AA52-A4329031AEEE}" type="slidenum">
               <a:rPr lang="en-US" smtClean="0"/>
-              <a:t>13</a:t>
+              <a:t>14</a:t>
             </a:fld>
             <a:endParaRPr lang="en-US"/>
           </a:p>
@@ -1192,7 +1333,7 @@
 </p:notes>
 </file>
 
-<file path=ppt/notesSlides/notesSlide14.xml><?xml version="1.0" encoding="utf-8"?>
+<file path=ppt/notesSlides/notesSlide15.xml><?xml version="1.0" encoding="utf-8"?>
 <p:notes xmlns:a="http://schemas.openxmlformats.org/drawingml/2006/main" xmlns:r="http://schemas.openxmlformats.org/officeDocument/2006/relationships" xmlns:p="http://schemas.openxmlformats.org/presentationml/2006/main">
   <p:cSld>
     <p:spTree>
@@ -1281,7 +1422,7 @@
           <a:p>
             <a:fld id="{AC44E78C-583C-4D47-AA52-A4329031AEEE}" type="slidenum">
               <a:rPr lang="en-US" smtClean="0"/>
-              <a:t>14</a:t>
+              <a:t>15</a:t>
             </a:fld>
             <a:endParaRPr lang="en-US"/>
           </a:p>
@@ -1300,7 +1441,7 @@
 </p:notes>
 </file>
 
-<file path=ppt/notesSlides/notesSlide15.xml><?xml version="1.0" encoding="utf-8"?>
+<file path=ppt/notesSlides/notesSlide16.xml><?xml version="1.0" encoding="utf-8"?>
 <p:notes xmlns:a="http://schemas.openxmlformats.org/drawingml/2006/main" xmlns:r="http://schemas.openxmlformats.org/officeDocument/2006/relationships" xmlns:p="http://schemas.openxmlformats.org/presentationml/2006/main">
   <p:cSld>
     <p:spTree>
@@ -1389,7 +1530,7 @@
           <a:p>
             <a:fld id="{AC44E78C-583C-4D47-AA52-A4329031AEEE}" type="slidenum">
               <a:rPr lang="en-US" smtClean="0"/>
-              <a:t>15</a:t>
+              <a:t>16</a:t>
             </a:fld>
             <a:endParaRPr lang="en-US"/>
           </a:p>
@@ -1408,7 +1549,7 @@
 </p:notes>
 </file>
 
-<file path=ppt/notesSlides/notesSlide16.xml><?xml version="1.0" encoding="utf-8"?>
+<file path=ppt/notesSlides/notesSlide17.xml><?xml version="1.0" encoding="utf-8"?>
 <p:notes xmlns:a="http://schemas.openxmlformats.org/drawingml/2006/main" xmlns:r="http://schemas.openxmlformats.org/officeDocument/2006/relationships" xmlns:p="http://schemas.openxmlformats.org/presentationml/2006/main">
   <p:cSld>
     <p:spTree>
@@ -1497,7 +1638,7 @@
           <a:p>
             <a:fld id="{AC44E78C-583C-4D47-AA52-A4329031AEEE}" type="slidenum">
               <a:rPr lang="en-US" smtClean="0"/>
-              <a:t>16</a:t>
+              <a:t>17</a:t>
             </a:fld>
             <a:endParaRPr lang="en-US"/>
           </a:p>
@@ -1516,7 +1657,7 @@
 </p:notes>
 </file>
 
-<file path=ppt/notesSlides/notesSlide17.xml><?xml version="1.0" encoding="utf-8"?>
+<file path=ppt/notesSlides/notesSlide18.xml><?xml version="1.0" encoding="utf-8"?>
 <p:notes xmlns:a="http://schemas.openxmlformats.org/drawingml/2006/main" xmlns:r="http://schemas.openxmlformats.org/officeDocument/2006/relationships" xmlns:p="http://schemas.openxmlformats.org/presentationml/2006/main">
   <p:cSld>
     <p:spTree>
@@ -1605,7 +1746,7 @@
           <a:p>
             <a:fld id="{AC44E78C-583C-4D47-AA52-A4329031AEEE}" type="slidenum">
               <a:rPr lang="en-US" smtClean="0"/>
-              <a:t>17</a:t>
+              <a:t>18</a:t>
             </a:fld>
             <a:endParaRPr lang="en-US"/>
           </a:p>
@@ -1624,7 +1765,7 @@
 </p:notes>
 </file>
 
-<file path=ppt/notesSlides/notesSlide18.xml><?xml version="1.0" encoding="utf-8"?>
+<file path=ppt/notesSlides/notesSlide19.xml><?xml version="1.0" encoding="utf-8"?>
 <p:notes xmlns:a="http://schemas.openxmlformats.org/drawingml/2006/main" xmlns:r="http://schemas.openxmlformats.org/officeDocument/2006/relationships" xmlns:p="http://schemas.openxmlformats.org/presentationml/2006/main">
   <p:cSld>
     <p:spTree>
@@ -1713,7 +1854,7 @@
           <a:p>
             <a:fld id="{AC44E78C-583C-4D47-AA52-A4329031AEEE}" type="slidenum">
               <a:rPr lang="en-US" smtClean="0"/>
-              <a:t>18</a:t>
+              <a:t>19</a:t>
             </a:fld>
             <a:endParaRPr lang="en-US"/>
           </a:p>
@@ -1723,90 +1864,6 @@
     <p:extLst>
       <p:ext uri="{BB962C8B-B14F-4D97-AF65-F5344CB8AC3E}">
         <p14:creationId xmlns:p14="http://schemas.microsoft.com/office/powerpoint/2010/main" val="1992751401"/>
-      </p:ext>
-    </p:extLst>
-  </p:cSld>
-  <p:clrMapOvr>
-    <a:masterClrMapping/>
-  </p:clrMapOvr>
-</p:notes>
-</file>
-
-<file path=ppt/notesSlides/notesSlide19.xml><?xml version="1.0" encoding="utf-8"?>
-<p:notes xmlns:a="http://schemas.openxmlformats.org/drawingml/2006/main" xmlns:r="http://schemas.openxmlformats.org/officeDocument/2006/relationships" xmlns:p="http://schemas.openxmlformats.org/presentationml/2006/main">
-  <p:cSld>
-    <p:spTree>
-      <p:nvGrpSpPr>
-        <p:cNvPr id="1" name=""/>
-        <p:cNvGrpSpPr/>
-        <p:nvPr/>
-      </p:nvGrpSpPr>
-      <p:grpSpPr>
-        <a:xfrm>
-          <a:off x="0" y="0"/>
-          <a:ext cx="0" cy="0"/>
-          <a:chOff x="0" y="0"/>
-          <a:chExt cx="0" cy="0"/>
-        </a:xfrm>
-      </p:grpSpPr>
-      <p:sp>
-        <p:nvSpPr>
-          <p:cNvPr id="2" name="Slide Image Placeholder 1"/>
-          <p:cNvSpPr>
-            <a:spLocks noGrp="1" noRot="1" noChangeAspect="1"/>
-          </p:cNvSpPr>
-          <p:nvPr>
-            <p:ph type="sldImg"/>
-          </p:nvPr>
-        </p:nvSpPr>
-        <p:spPr/>
-      </p:sp>
-      <p:sp>
-        <p:nvSpPr>
-          <p:cNvPr id="3" name="Notes Placeholder 2"/>
-          <p:cNvSpPr>
-            <a:spLocks noGrp="1"/>
-          </p:cNvSpPr>
-          <p:nvPr>
-            <p:ph type="body" idx="1"/>
-          </p:nvPr>
-        </p:nvSpPr>
-        <p:spPr/>
-        <p:txBody>
-          <a:bodyPr/>
-          <a:lstStyle/>
-          <a:p>
-            <a:endParaRPr lang="en-US" dirty="0"/>
-          </a:p>
-        </p:txBody>
-      </p:sp>
-      <p:sp>
-        <p:nvSpPr>
-          <p:cNvPr id="4" name="Slide Number Placeholder 3"/>
-          <p:cNvSpPr>
-            <a:spLocks noGrp="1"/>
-          </p:cNvSpPr>
-          <p:nvPr>
-            <p:ph type="sldNum" sz="quarter" idx="5"/>
-          </p:nvPr>
-        </p:nvSpPr>
-        <p:spPr/>
-        <p:txBody>
-          <a:bodyPr/>
-          <a:lstStyle/>
-          <a:p>
-            <a:fld id="{AC44E78C-583C-4D47-AA52-A4329031AEEE}" type="slidenum">
-              <a:rPr lang="en-US" smtClean="0"/>
-              <a:t>19</a:t>
-            </a:fld>
-            <a:endParaRPr lang="en-US"/>
-          </a:p>
-        </p:txBody>
-      </p:sp>
-    </p:spTree>
-    <p:extLst>
-      <p:ext uri="{BB962C8B-B14F-4D97-AF65-F5344CB8AC3E}">
-        <p14:creationId xmlns:p14="http://schemas.microsoft.com/office/powerpoint/2010/main" val="96948810"/>
       </p:ext>
     </p:extLst>
   </p:cSld>
@@ -1824,7 +1881,7 @@
         <p:cNvPr id="1" name="">
           <a:extLst>
             <a:ext uri="{FF2B5EF4-FFF2-40B4-BE49-F238E27FC236}">
-              <a16:creationId xmlns:a16="http://schemas.microsoft.com/office/drawing/2014/main" id="{EC0C2C15-1DEE-902E-6436-518E9054E3AF}"/>
+              <a16:creationId xmlns:a16="http://schemas.microsoft.com/office/drawing/2014/main" id="{973045E5-73AF-A03E-AE7A-A2FAA75D16FA}"/>
             </a:ext>
           </a:extLst>
         </p:cNvPr>
@@ -1844,7 +1901,7 @@
           <p:cNvPr id="2" name="Slide Image Placeholder 1">
             <a:extLst>
               <a:ext uri="{FF2B5EF4-FFF2-40B4-BE49-F238E27FC236}">
-                <a16:creationId xmlns:a16="http://schemas.microsoft.com/office/drawing/2014/main" id="{1D2B1B15-1DCB-99D4-4643-035B451E958A}"/>
+                <a16:creationId xmlns:a16="http://schemas.microsoft.com/office/drawing/2014/main" id="{33D9BCCE-BC71-6DAC-4D10-709AC6739E89}"/>
               </a:ext>
             </a:extLst>
           </p:cNvPr>
@@ -1862,7 +1919,7 @@
           <p:cNvPr id="3" name="Notes Placeholder 2">
             <a:extLst>
               <a:ext uri="{FF2B5EF4-FFF2-40B4-BE49-F238E27FC236}">
-                <a16:creationId xmlns:a16="http://schemas.microsoft.com/office/drawing/2014/main" id="{A40FBCE5-E8CE-A66A-0249-4EA920F2474B}"/>
+                <a16:creationId xmlns:a16="http://schemas.microsoft.com/office/drawing/2014/main" id="{5CE0EE15-8E70-13B9-494D-2C658EDE794F}"/>
               </a:ext>
             </a:extLst>
           </p:cNvPr>
@@ -1887,7 +1944,7 @@
           <p:cNvPr id="4" name="Slide Number Placeholder 3">
             <a:extLst>
               <a:ext uri="{FF2B5EF4-FFF2-40B4-BE49-F238E27FC236}">
-                <a16:creationId xmlns:a16="http://schemas.microsoft.com/office/drawing/2014/main" id="{536121E8-BF5F-2B68-6A48-A85E122D2DEB}"/>
+                <a16:creationId xmlns:a16="http://schemas.microsoft.com/office/drawing/2014/main" id="{3098D2F7-E928-E4F3-8F53-7E2C1122C454}"/>
               </a:ext>
             </a:extLst>
           </p:cNvPr>
@@ -1914,7 +1971,7 @@
     </p:spTree>
     <p:extLst>
       <p:ext uri="{BB962C8B-B14F-4D97-AF65-F5344CB8AC3E}">
-        <p14:creationId xmlns:p14="http://schemas.microsoft.com/office/powerpoint/2010/main" val="11037324"/>
+        <p14:creationId xmlns:p14="http://schemas.microsoft.com/office/powerpoint/2010/main" val="2168950448"/>
       </p:ext>
     </p:extLst>
   </p:cSld>
@@ -1925,6 +1982,90 @@
 </file>
 
 <file path=ppt/notesSlides/notesSlide20.xml><?xml version="1.0" encoding="utf-8"?>
+<p:notes xmlns:a="http://schemas.openxmlformats.org/drawingml/2006/main" xmlns:r="http://schemas.openxmlformats.org/officeDocument/2006/relationships" xmlns:p="http://schemas.openxmlformats.org/presentationml/2006/main">
+  <p:cSld>
+    <p:spTree>
+      <p:nvGrpSpPr>
+        <p:cNvPr id="1" name=""/>
+        <p:cNvGrpSpPr/>
+        <p:nvPr/>
+      </p:nvGrpSpPr>
+      <p:grpSpPr>
+        <a:xfrm>
+          <a:off x="0" y="0"/>
+          <a:ext cx="0" cy="0"/>
+          <a:chOff x="0" y="0"/>
+          <a:chExt cx="0" cy="0"/>
+        </a:xfrm>
+      </p:grpSpPr>
+      <p:sp>
+        <p:nvSpPr>
+          <p:cNvPr id="2" name="Slide Image Placeholder 1"/>
+          <p:cNvSpPr>
+            <a:spLocks noGrp="1" noRot="1" noChangeAspect="1"/>
+          </p:cNvSpPr>
+          <p:nvPr>
+            <p:ph type="sldImg"/>
+          </p:nvPr>
+        </p:nvSpPr>
+        <p:spPr/>
+      </p:sp>
+      <p:sp>
+        <p:nvSpPr>
+          <p:cNvPr id="3" name="Notes Placeholder 2"/>
+          <p:cNvSpPr>
+            <a:spLocks noGrp="1"/>
+          </p:cNvSpPr>
+          <p:nvPr>
+            <p:ph type="body" idx="1"/>
+          </p:nvPr>
+        </p:nvSpPr>
+        <p:spPr/>
+        <p:txBody>
+          <a:bodyPr/>
+          <a:lstStyle/>
+          <a:p>
+            <a:endParaRPr lang="en-US" dirty="0"/>
+          </a:p>
+        </p:txBody>
+      </p:sp>
+      <p:sp>
+        <p:nvSpPr>
+          <p:cNvPr id="4" name="Slide Number Placeholder 3"/>
+          <p:cNvSpPr>
+            <a:spLocks noGrp="1"/>
+          </p:cNvSpPr>
+          <p:nvPr>
+            <p:ph type="sldNum" sz="quarter" idx="5"/>
+          </p:nvPr>
+        </p:nvSpPr>
+        <p:spPr/>
+        <p:txBody>
+          <a:bodyPr/>
+          <a:lstStyle/>
+          <a:p>
+            <a:fld id="{AC44E78C-583C-4D47-AA52-A4329031AEEE}" type="slidenum">
+              <a:rPr lang="en-US" smtClean="0"/>
+              <a:t>20</a:t>
+            </a:fld>
+            <a:endParaRPr lang="en-US"/>
+          </a:p>
+        </p:txBody>
+      </p:sp>
+    </p:spTree>
+    <p:extLst>
+      <p:ext uri="{BB962C8B-B14F-4D97-AF65-F5344CB8AC3E}">
+        <p14:creationId xmlns:p14="http://schemas.microsoft.com/office/powerpoint/2010/main" val="96948810"/>
+      </p:ext>
+    </p:extLst>
+  </p:cSld>
+  <p:clrMapOvr>
+    <a:masterClrMapping/>
+  </p:clrMapOvr>
+</p:notes>
+</file>
+
+<file path=ppt/notesSlides/notesSlide21.xml><?xml version="1.0" encoding="utf-8"?>
 <p:notes xmlns:a="http://schemas.openxmlformats.org/drawingml/2006/main" xmlns:r="http://schemas.openxmlformats.org/officeDocument/2006/relationships" xmlns:p="http://schemas.openxmlformats.org/presentationml/2006/main">
   <p:cSld>
     <p:spTree>
@@ -2013,7 +2154,7 @@
           <a:p>
             <a:fld id="{AC44E78C-583C-4D47-AA52-A4329031AEEE}" type="slidenum">
               <a:rPr lang="en-US" smtClean="0"/>
-              <a:t>20</a:t>
+              <a:t>21</a:t>
             </a:fld>
             <a:endParaRPr lang="en-US"/>
           </a:p>
@@ -2032,7 +2173,7 @@
 </p:notes>
 </file>
 
-<file path=ppt/notesSlides/notesSlide21.xml><?xml version="1.0" encoding="utf-8"?>
+<file path=ppt/notesSlides/notesSlide22.xml><?xml version="1.0" encoding="utf-8"?>
 <p:notes xmlns:a="http://schemas.openxmlformats.org/drawingml/2006/main" xmlns:r="http://schemas.openxmlformats.org/officeDocument/2006/relationships" xmlns:p="http://schemas.openxmlformats.org/presentationml/2006/main">
   <p:cSld>
     <p:spTree>
@@ -2121,7 +2262,7 @@
           <a:p>
             <a:fld id="{AC44E78C-583C-4D47-AA52-A4329031AEEE}" type="slidenum">
               <a:rPr lang="en-US" smtClean="0"/>
-              <a:t>22</a:t>
+              <a:t>23</a:t>
             </a:fld>
             <a:endParaRPr lang="en-US"/>
           </a:p>
@@ -2140,7 +2281,7 @@
 </p:notes>
 </file>
 
-<file path=ppt/notesSlides/notesSlide22.xml><?xml version="1.0" encoding="utf-8"?>
+<file path=ppt/notesSlides/notesSlide23.xml><?xml version="1.0" encoding="utf-8"?>
 <p:notes xmlns:a="http://schemas.openxmlformats.org/drawingml/2006/main" xmlns:r="http://schemas.openxmlformats.org/officeDocument/2006/relationships" xmlns:p="http://schemas.openxmlformats.org/presentationml/2006/main">
   <p:cSld>
     <p:spTree>
@@ -2229,7 +2370,7 @@
           <a:p>
             <a:fld id="{AC44E78C-583C-4D47-AA52-A4329031AEEE}" type="slidenum">
               <a:rPr lang="en-US" smtClean="0"/>
-              <a:t>23</a:t>
+              <a:t>24</a:t>
             </a:fld>
             <a:endParaRPr lang="en-US"/>
           </a:p>
@@ -2248,7 +2389,7 @@
 </p:notes>
 </file>
 
-<file path=ppt/notesSlides/notesSlide23.xml><?xml version="1.0" encoding="utf-8"?>
+<file path=ppt/notesSlides/notesSlide24.xml><?xml version="1.0" encoding="utf-8"?>
 <p:notes xmlns:a="http://schemas.openxmlformats.org/drawingml/2006/main" xmlns:r="http://schemas.openxmlformats.org/officeDocument/2006/relationships" xmlns:p="http://schemas.openxmlformats.org/presentationml/2006/main">
   <p:cSld>
     <p:spTree>
@@ -2337,7 +2478,7 @@
           <a:p>
             <a:fld id="{AC44E78C-583C-4D47-AA52-A4329031AEEE}" type="slidenum">
               <a:rPr lang="en-US" smtClean="0"/>
-              <a:t>24</a:t>
+              <a:t>25</a:t>
             </a:fld>
             <a:endParaRPr lang="en-US"/>
           </a:p>
@@ -2356,7 +2497,7 @@
 </p:notes>
 </file>
 
-<file path=ppt/notesSlides/notesSlide24.xml><?xml version="1.0" encoding="utf-8"?>
+<file path=ppt/notesSlides/notesSlide25.xml><?xml version="1.0" encoding="utf-8"?>
 <p:notes xmlns:a="http://schemas.openxmlformats.org/drawingml/2006/main" xmlns:r="http://schemas.openxmlformats.org/officeDocument/2006/relationships" xmlns:p="http://schemas.openxmlformats.org/presentationml/2006/main">
   <p:cSld>
     <p:spTree>
@@ -2445,7 +2586,7 @@
           <a:p>
             <a:fld id="{AC44E78C-583C-4D47-AA52-A4329031AEEE}" type="slidenum">
               <a:rPr lang="en-US" smtClean="0"/>
-              <a:t>25</a:t>
+              <a:t>26</a:t>
             </a:fld>
             <a:endParaRPr lang="en-US"/>
           </a:p>
@@ -2464,7 +2605,7 @@
 </p:notes>
 </file>
 
-<file path=ppt/notesSlides/notesSlide25.xml><?xml version="1.0" encoding="utf-8"?>
+<file path=ppt/notesSlides/notesSlide26.xml><?xml version="1.0" encoding="utf-8"?>
 <p:notes xmlns:a="http://schemas.openxmlformats.org/drawingml/2006/main" xmlns:r="http://schemas.openxmlformats.org/officeDocument/2006/relationships" xmlns:p="http://schemas.openxmlformats.org/presentationml/2006/main">
   <p:cSld>
     <p:spTree>
@@ -2553,7 +2694,7 @@
           <a:p>
             <a:fld id="{AC44E78C-583C-4D47-AA52-A4329031AEEE}" type="slidenum">
               <a:rPr lang="en-US" smtClean="0"/>
-              <a:t>26</a:t>
+              <a:t>27</a:t>
             </a:fld>
             <a:endParaRPr lang="en-US"/>
           </a:p>
@@ -2563,123 +2704,6 @@
     <p:extLst>
       <p:ext uri="{BB962C8B-B14F-4D97-AF65-F5344CB8AC3E}">
         <p14:creationId xmlns:p14="http://schemas.microsoft.com/office/powerpoint/2010/main" val="4018611128"/>
-      </p:ext>
-    </p:extLst>
-  </p:cSld>
-  <p:clrMapOvr>
-    <a:masterClrMapping/>
-  </p:clrMapOvr>
-</p:notes>
-</file>
-
-<file path=ppt/notesSlides/notesSlide26.xml><?xml version="1.0" encoding="utf-8"?>
-<p:notes xmlns:a="http://schemas.openxmlformats.org/drawingml/2006/main" xmlns:r="http://schemas.openxmlformats.org/officeDocument/2006/relationships" xmlns:p="http://schemas.openxmlformats.org/presentationml/2006/main">
-  <p:cSld>
-    <p:spTree>
-      <p:nvGrpSpPr>
-        <p:cNvPr id="1" name=""/>
-        <p:cNvGrpSpPr/>
-        <p:nvPr/>
-      </p:nvGrpSpPr>
-      <p:grpSpPr>
-        <a:xfrm>
-          <a:off x="0" y="0"/>
-          <a:ext cx="0" cy="0"/>
-          <a:chOff x="0" y="0"/>
-          <a:chExt cx="0" cy="0"/>
-        </a:xfrm>
-      </p:grpSpPr>
-      <p:sp>
-        <p:nvSpPr>
-          <p:cNvPr id="2" name="Slide Image Placeholder 1"/>
-          <p:cNvSpPr>
-            <a:spLocks noGrp="1" noRot="1" noChangeAspect="1"/>
-          </p:cNvSpPr>
-          <p:nvPr>
-            <p:ph type="sldImg"/>
-          </p:nvPr>
-        </p:nvSpPr>
-        <p:spPr/>
-      </p:sp>
-      <p:sp>
-        <p:nvSpPr>
-          <p:cNvPr id="3" name="Notes Placeholder 2"/>
-          <p:cNvSpPr>
-            <a:spLocks noGrp="1"/>
-          </p:cNvSpPr>
-          <p:nvPr>
-            <p:ph type="body" idx="1"/>
-          </p:nvPr>
-        </p:nvSpPr>
-        <p:spPr/>
-        <p:txBody>
-          <a:bodyPr/>
-          <a:lstStyle/>
-          <a:p>
-            <a:r>
-              <a:rPr lang="en-US" dirty="0" err="1"/>
-              <a:t>Defq</a:t>
-            </a:r>
-            <a:r>
-              <a:rPr lang="en-US" dirty="0"/>
-              <a:t> is the one for accessing normal HPC nodes. This is probably the main queue you will want to use</a:t>
-            </a:r>
-          </a:p>
-          <a:p>
-            <a:r>
-              <a:rPr lang="en-US" dirty="0"/>
-              <a:t>If you need to run jobs with more than 361 GB memory e.g. genome assemblies you would use </a:t>
-            </a:r>
-            <a:r>
-              <a:rPr lang="en-US" dirty="0" err="1"/>
-              <a:t>hmemq</a:t>
-            </a:r>
-            <a:endParaRPr lang="en-US" dirty="0"/>
-          </a:p>
-          <a:p>
-            <a:r>
-              <a:rPr lang="en-US" dirty="0"/>
-              <a:t>If you want access to GPU nodes use ampere</a:t>
-            </a:r>
-          </a:p>
-          <a:p>
-            <a:endParaRPr lang="en-US" dirty="0"/>
-          </a:p>
-          <a:p>
-            <a:r>
-              <a:rPr lang="en-US" dirty="0"/>
-              <a:t>GPU – graphics processing Unit</a:t>
-            </a:r>
-          </a:p>
-        </p:txBody>
-      </p:sp>
-      <p:sp>
-        <p:nvSpPr>
-          <p:cNvPr id="4" name="Slide Number Placeholder 3"/>
-          <p:cNvSpPr>
-            <a:spLocks noGrp="1"/>
-          </p:cNvSpPr>
-          <p:nvPr>
-            <p:ph type="sldNum" sz="quarter" idx="5"/>
-          </p:nvPr>
-        </p:nvSpPr>
-        <p:spPr/>
-        <p:txBody>
-          <a:bodyPr/>
-          <a:lstStyle/>
-          <a:p>
-            <a:fld id="{AC44E78C-583C-4D47-AA52-A4329031AEEE}" type="slidenum">
-              <a:rPr lang="en-US" smtClean="0"/>
-              <a:t>27</a:t>
-            </a:fld>
-            <a:endParaRPr lang="en-US"/>
-          </a:p>
-        </p:txBody>
-      </p:sp>
-    </p:spTree>
-    <p:extLst>
-      <p:ext uri="{BB962C8B-B14F-4D97-AF65-F5344CB8AC3E}">
-        <p14:creationId xmlns:p14="http://schemas.microsoft.com/office/powerpoint/2010/main" val="260722985"/>
       </p:ext>
     </p:extLst>
   </p:cSld>
@@ -2734,32 +2758,38 @@
           <a:lstStyle/>
           <a:p>
             <a:r>
-              <a:rPr lang="en-US" dirty="0"/>
-              <a:t>Software on Ada must be loaded from environment modules</a:t>
-            </a:r>
-          </a:p>
-          <a:p>
-            <a:r>
-              <a:rPr lang="en-US" dirty="0"/>
-              <a:t>To list all available software use module avail</a:t>
-            </a:r>
-          </a:p>
-          <a:p>
-            <a:r>
-              <a:rPr lang="en-US" dirty="0"/>
-              <a:t>S by a module means the module is sticky and requires the –force flag to unload (you shouldn’t need to mess with these!</a:t>
-            </a:r>
-          </a:p>
-          <a:p>
-            <a:r>
-              <a:rPr lang="en-US" dirty="0"/>
-              <a:t>L by a module means the module is currently loaded</a:t>
-            </a:r>
-          </a:p>
-          <a:p>
-            <a:r>
-              <a:rPr lang="en-US" dirty="0"/>
-              <a:t>D by a module means this is the default version of the software</a:t>
+              <a:rPr lang="en-US" dirty="0" err="1"/>
+              <a:t>Defq</a:t>
+            </a:r>
+            <a:r>
+              <a:rPr lang="en-US" dirty="0"/>
+              <a:t> is the one for accessing normal HPC nodes. This is probably the main queue you will want to use</a:t>
+            </a:r>
+          </a:p>
+          <a:p>
+            <a:r>
+              <a:rPr lang="en-US" dirty="0"/>
+              <a:t>If you need to run jobs with more than 361 GB memory e.g. genome assemblies you would use </a:t>
+            </a:r>
+            <a:r>
+              <a:rPr lang="en-US" dirty="0" err="1"/>
+              <a:t>hmemq</a:t>
+            </a:r>
+            <a:endParaRPr lang="en-US" dirty="0"/>
+          </a:p>
+          <a:p>
+            <a:r>
+              <a:rPr lang="en-US" dirty="0"/>
+              <a:t>If you want access to GPU nodes use ampere</a:t>
+            </a:r>
+          </a:p>
+          <a:p>
+            <a:endParaRPr lang="en-US" dirty="0"/>
+          </a:p>
+          <a:p>
+            <a:r>
+              <a:rPr lang="en-US" dirty="0"/>
+              <a:t>GPU – graphics processing Unit</a:t>
             </a:r>
           </a:p>
         </p:txBody>
@@ -2781,7 +2811,7 @@
           <a:p>
             <a:fld id="{AC44E78C-583C-4D47-AA52-A4329031AEEE}" type="slidenum">
               <a:rPr lang="en-US" smtClean="0"/>
-              <a:t>29</a:t>
+              <a:t>28</a:t>
             </a:fld>
             <a:endParaRPr lang="en-US"/>
           </a:p>
@@ -2790,7 +2820,7 @@
     </p:spTree>
     <p:extLst>
       <p:ext uri="{BB962C8B-B14F-4D97-AF65-F5344CB8AC3E}">
-        <p14:creationId xmlns:p14="http://schemas.microsoft.com/office/powerpoint/2010/main" val="3516832243"/>
+        <p14:creationId xmlns:p14="http://schemas.microsoft.com/office/powerpoint/2010/main" val="260722985"/>
       </p:ext>
     </p:extLst>
   </p:cSld>
@@ -2852,35 +2882,26 @@
           <a:p>
             <a:r>
               <a:rPr lang="en-US" dirty="0"/>
-              <a:t>To search for a specific software use module avail </a:t>
-            </a:r>
-            <a:r>
-              <a:rPr lang="en-US" dirty="0" err="1"/>
-              <a:t>software_name</a:t>
-            </a:r>
-            <a:endParaRPr lang="en-US" dirty="0"/>
-          </a:p>
-          <a:p>
-            <a:r>
-              <a:rPr lang="en-US" dirty="0"/>
-              <a:t>To load modules use module load </a:t>
-            </a:r>
-            <a:r>
-              <a:rPr lang="en-US" dirty="0" err="1"/>
-              <a:t>module_name</a:t>
-            </a:r>
-            <a:endParaRPr lang="en-US" dirty="0"/>
-          </a:p>
-          <a:p>
-            <a:r>
-              <a:rPr lang="en-US" dirty="0"/>
-              <a:t>To unload use module unload </a:t>
-            </a:r>
-            <a:r>
-              <a:rPr lang="en-US" dirty="0" err="1"/>
-              <a:t>module_name</a:t>
-            </a:r>
-            <a:endParaRPr lang="en-US" dirty="0"/>
+              <a:t>To list all available software use module avail</a:t>
+            </a:r>
+          </a:p>
+          <a:p>
+            <a:r>
+              <a:rPr lang="en-US" dirty="0"/>
+              <a:t>S by a module means the module is sticky and requires the –force flag to unload (you shouldn’t need to mess with these!</a:t>
+            </a:r>
+          </a:p>
+          <a:p>
+            <a:r>
+              <a:rPr lang="en-US" dirty="0"/>
+              <a:t>L by a module means the module is currently loaded</a:t>
+            </a:r>
+          </a:p>
+          <a:p>
+            <a:r>
+              <a:rPr lang="en-US" dirty="0"/>
+              <a:t>D by a module means this is the default version of the software</a:t>
+            </a:r>
           </a:p>
         </p:txBody>
       </p:sp>
@@ -2902,6 +2923,126 @@
             <a:fld id="{AC44E78C-583C-4D47-AA52-A4329031AEEE}" type="slidenum">
               <a:rPr lang="en-US" smtClean="0"/>
               <a:t>30</a:t>
+            </a:fld>
+            <a:endParaRPr lang="en-US"/>
+          </a:p>
+        </p:txBody>
+      </p:sp>
+    </p:spTree>
+    <p:extLst>
+      <p:ext uri="{BB962C8B-B14F-4D97-AF65-F5344CB8AC3E}">
+        <p14:creationId xmlns:p14="http://schemas.microsoft.com/office/powerpoint/2010/main" val="3516832243"/>
+      </p:ext>
+    </p:extLst>
+  </p:cSld>
+  <p:clrMapOvr>
+    <a:masterClrMapping/>
+  </p:clrMapOvr>
+</p:notes>
+</file>
+
+<file path=ppt/notesSlides/notesSlide29.xml><?xml version="1.0" encoding="utf-8"?>
+<p:notes xmlns:a="http://schemas.openxmlformats.org/drawingml/2006/main" xmlns:r="http://schemas.openxmlformats.org/officeDocument/2006/relationships" xmlns:p="http://schemas.openxmlformats.org/presentationml/2006/main">
+  <p:cSld>
+    <p:spTree>
+      <p:nvGrpSpPr>
+        <p:cNvPr id="1" name=""/>
+        <p:cNvGrpSpPr/>
+        <p:nvPr/>
+      </p:nvGrpSpPr>
+      <p:grpSpPr>
+        <a:xfrm>
+          <a:off x="0" y="0"/>
+          <a:ext cx="0" cy="0"/>
+          <a:chOff x="0" y="0"/>
+          <a:chExt cx="0" cy="0"/>
+        </a:xfrm>
+      </p:grpSpPr>
+      <p:sp>
+        <p:nvSpPr>
+          <p:cNvPr id="2" name="Slide Image Placeholder 1"/>
+          <p:cNvSpPr>
+            <a:spLocks noGrp="1" noRot="1" noChangeAspect="1"/>
+          </p:cNvSpPr>
+          <p:nvPr>
+            <p:ph type="sldImg"/>
+          </p:nvPr>
+        </p:nvSpPr>
+        <p:spPr/>
+      </p:sp>
+      <p:sp>
+        <p:nvSpPr>
+          <p:cNvPr id="3" name="Notes Placeholder 2"/>
+          <p:cNvSpPr>
+            <a:spLocks noGrp="1"/>
+          </p:cNvSpPr>
+          <p:nvPr>
+            <p:ph type="body" idx="1"/>
+          </p:nvPr>
+        </p:nvSpPr>
+        <p:spPr/>
+        <p:txBody>
+          <a:bodyPr/>
+          <a:lstStyle/>
+          <a:p>
+            <a:r>
+              <a:rPr lang="en-US" dirty="0"/>
+              <a:t>Software on Ada must be loaded from environment modules</a:t>
+            </a:r>
+          </a:p>
+          <a:p>
+            <a:r>
+              <a:rPr lang="en-US" dirty="0"/>
+              <a:t>To search for a specific software use module avail </a:t>
+            </a:r>
+            <a:r>
+              <a:rPr lang="en-US" dirty="0" err="1"/>
+              <a:t>software_name</a:t>
+            </a:r>
+            <a:endParaRPr lang="en-US" dirty="0"/>
+          </a:p>
+          <a:p>
+            <a:r>
+              <a:rPr lang="en-US" dirty="0"/>
+              <a:t>To load modules use module load </a:t>
+            </a:r>
+            <a:r>
+              <a:rPr lang="en-US" dirty="0" err="1"/>
+              <a:t>module_name</a:t>
+            </a:r>
+            <a:endParaRPr lang="en-US" dirty="0"/>
+          </a:p>
+          <a:p>
+            <a:r>
+              <a:rPr lang="en-US" dirty="0"/>
+              <a:t>To unload use module unload </a:t>
+            </a:r>
+            <a:r>
+              <a:rPr lang="en-US" dirty="0" err="1"/>
+              <a:t>module_name</a:t>
+            </a:r>
+            <a:endParaRPr lang="en-US" dirty="0"/>
+          </a:p>
+        </p:txBody>
+      </p:sp>
+      <p:sp>
+        <p:nvSpPr>
+          <p:cNvPr id="4" name="Slide Number Placeholder 3"/>
+          <p:cNvSpPr>
+            <a:spLocks noGrp="1"/>
+          </p:cNvSpPr>
+          <p:nvPr>
+            <p:ph type="sldNum" sz="quarter" idx="5"/>
+          </p:nvPr>
+        </p:nvSpPr>
+        <p:spPr/>
+        <p:txBody>
+          <a:bodyPr/>
+          <a:lstStyle/>
+          <a:p>
+            <a:fld id="{AC44E78C-583C-4D47-AA52-A4329031AEEE}" type="slidenum">
+              <a:rPr lang="en-US" smtClean="0"/>
+              <a:t>31</a:t>
             </a:fld>
             <a:endParaRPr lang="en-US"/>
           </a:p>
@@ -2920,7 +3061,115 @@
 </p:notes>
 </file>
 
-<file path=ppt/notesSlides/notesSlide29.xml><?xml version="1.0" encoding="utf-8"?>
+<file path=ppt/notesSlides/notesSlide3.xml><?xml version="1.0" encoding="utf-8"?>
+<p:notes xmlns:a="http://schemas.openxmlformats.org/drawingml/2006/main" xmlns:r="http://schemas.openxmlformats.org/officeDocument/2006/relationships" xmlns:p="http://schemas.openxmlformats.org/presentationml/2006/main">
+  <p:cSld>
+    <p:spTree>
+      <p:nvGrpSpPr>
+        <p:cNvPr id="1" name="">
+          <a:extLst>
+            <a:ext uri="{FF2B5EF4-FFF2-40B4-BE49-F238E27FC236}">
+              <a16:creationId xmlns:a16="http://schemas.microsoft.com/office/drawing/2014/main" id="{EC0C2C15-1DEE-902E-6436-518E9054E3AF}"/>
+            </a:ext>
+          </a:extLst>
+        </p:cNvPr>
+        <p:cNvGrpSpPr/>
+        <p:nvPr/>
+      </p:nvGrpSpPr>
+      <p:grpSpPr>
+        <a:xfrm>
+          <a:off x="0" y="0"/>
+          <a:ext cx="0" cy="0"/>
+          <a:chOff x="0" y="0"/>
+          <a:chExt cx="0" cy="0"/>
+        </a:xfrm>
+      </p:grpSpPr>
+      <p:sp>
+        <p:nvSpPr>
+          <p:cNvPr id="2" name="Slide Image Placeholder 1">
+            <a:extLst>
+              <a:ext uri="{FF2B5EF4-FFF2-40B4-BE49-F238E27FC236}">
+                <a16:creationId xmlns:a16="http://schemas.microsoft.com/office/drawing/2014/main" id="{1D2B1B15-1DCB-99D4-4643-035B451E958A}"/>
+              </a:ext>
+            </a:extLst>
+          </p:cNvPr>
+          <p:cNvSpPr>
+            <a:spLocks noGrp="1" noRot="1" noChangeAspect="1"/>
+          </p:cNvSpPr>
+          <p:nvPr>
+            <p:ph type="sldImg"/>
+          </p:nvPr>
+        </p:nvSpPr>
+        <p:spPr/>
+      </p:sp>
+      <p:sp>
+        <p:nvSpPr>
+          <p:cNvPr id="3" name="Notes Placeholder 2">
+            <a:extLst>
+              <a:ext uri="{FF2B5EF4-FFF2-40B4-BE49-F238E27FC236}">
+                <a16:creationId xmlns:a16="http://schemas.microsoft.com/office/drawing/2014/main" id="{A40FBCE5-E8CE-A66A-0249-4EA920F2474B}"/>
+              </a:ext>
+            </a:extLst>
+          </p:cNvPr>
+          <p:cNvSpPr>
+            <a:spLocks noGrp="1"/>
+          </p:cNvSpPr>
+          <p:nvPr>
+            <p:ph type="body" idx="1"/>
+          </p:nvPr>
+        </p:nvSpPr>
+        <p:spPr/>
+        <p:txBody>
+          <a:bodyPr/>
+          <a:lstStyle/>
+          <a:p>
+            <a:endParaRPr lang="en-US" dirty="0"/>
+          </a:p>
+        </p:txBody>
+      </p:sp>
+      <p:sp>
+        <p:nvSpPr>
+          <p:cNvPr id="4" name="Slide Number Placeholder 3">
+            <a:extLst>
+              <a:ext uri="{FF2B5EF4-FFF2-40B4-BE49-F238E27FC236}">
+                <a16:creationId xmlns:a16="http://schemas.microsoft.com/office/drawing/2014/main" id="{536121E8-BF5F-2B68-6A48-A85E122D2DEB}"/>
+              </a:ext>
+            </a:extLst>
+          </p:cNvPr>
+          <p:cNvSpPr>
+            <a:spLocks noGrp="1"/>
+          </p:cNvSpPr>
+          <p:nvPr>
+            <p:ph type="sldNum" sz="quarter" idx="5"/>
+          </p:nvPr>
+        </p:nvSpPr>
+        <p:spPr/>
+        <p:txBody>
+          <a:bodyPr/>
+          <a:lstStyle/>
+          <a:p>
+            <a:fld id="{AC44E78C-583C-4D47-AA52-A4329031AEEE}" type="slidenum">
+              <a:rPr lang="en-US" smtClean="0"/>
+              <a:t>3</a:t>
+            </a:fld>
+            <a:endParaRPr lang="en-US"/>
+          </a:p>
+        </p:txBody>
+      </p:sp>
+    </p:spTree>
+    <p:extLst>
+      <p:ext uri="{BB962C8B-B14F-4D97-AF65-F5344CB8AC3E}">
+        <p14:creationId xmlns:p14="http://schemas.microsoft.com/office/powerpoint/2010/main" val="11037324"/>
+      </p:ext>
+    </p:extLst>
+  </p:cSld>
+  <p:clrMapOvr>
+    <a:masterClrMapping/>
+  </p:clrMapOvr>
+</p:notes>
+</file>
+
+<file path=ppt/notesSlides/notesSlide30.xml><?xml version="1.0" encoding="utf-8"?>
 <p:notes xmlns:a="http://schemas.openxmlformats.org/drawingml/2006/main" xmlns:r="http://schemas.openxmlformats.org/officeDocument/2006/relationships" xmlns:p="http://schemas.openxmlformats.org/presentationml/2006/main">
   <p:cSld>
     <p:spTree>
@@ -3045,7 +3294,7 @@
           <a:p>
             <a:fld id="{AC44E78C-583C-4D47-AA52-A4329031AEEE}" type="slidenum">
               <a:rPr lang="en-US" smtClean="0"/>
-              <a:t>31</a:t>
+              <a:t>32</a:t>
             </a:fld>
             <a:endParaRPr lang="en-US"/>
           </a:p>
@@ -3064,106 +3313,7 @@
 </p:notes>
 </file>
 
-<file path=ppt/notesSlides/notesSlide3.xml><?xml version="1.0" encoding="utf-8"?>
-<p:notes xmlns:a="http://schemas.openxmlformats.org/drawingml/2006/main" xmlns:r="http://schemas.openxmlformats.org/officeDocument/2006/relationships" xmlns:p="http://schemas.openxmlformats.org/presentationml/2006/main">
-  <p:cSld>
-    <p:spTree>
-      <p:nvGrpSpPr>
-        <p:cNvPr id="1" name=""/>
-        <p:cNvGrpSpPr/>
-        <p:nvPr/>
-      </p:nvGrpSpPr>
-      <p:grpSpPr>
-        <a:xfrm>
-          <a:off x="0" y="0"/>
-          <a:ext cx="0" cy="0"/>
-          <a:chOff x="0" y="0"/>
-          <a:chExt cx="0" cy="0"/>
-        </a:xfrm>
-      </p:grpSpPr>
-      <p:sp>
-        <p:nvSpPr>
-          <p:cNvPr id="2" name="Slide Image Placeholder 1"/>
-          <p:cNvSpPr>
-            <a:spLocks noGrp="1" noRot="1" noChangeAspect="1"/>
-          </p:cNvSpPr>
-          <p:nvPr>
-            <p:ph type="sldImg"/>
-          </p:nvPr>
-        </p:nvSpPr>
-        <p:spPr/>
-      </p:sp>
-      <p:sp>
-        <p:nvSpPr>
-          <p:cNvPr id="3" name="Notes Placeholder 2"/>
-          <p:cNvSpPr>
-            <a:spLocks noGrp="1"/>
-          </p:cNvSpPr>
-          <p:nvPr>
-            <p:ph type="body" idx="1"/>
-          </p:nvPr>
-        </p:nvSpPr>
-        <p:spPr/>
-        <p:txBody>
-          <a:bodyPr/>
-          <a:lstStyle/>
-          <a:p>
-            <a:r>
-              <a:rPr lang="en-US" dirty="0"/>
-              <a:t>SLURM – Simple Linux Utility for Resource Management.</a:t>
-            </a:r>
-          </a:p>
-          <a:p>
-            <a:r>
-              <a:rPr lang="en-US" dirty="0"/>
-              <a:t>The software we use to run our HPC.</a:t>
-            </a:r>
-          </a:p>
-          <a:p>
-            <a:r>
-              <a:rPr lang="en-US" dirty="0"/>
-              <a:t>This is one reason why you need to be competent Unix users!</a:t>
-            </a:r>
-          </a:p>
-        </p:txBody>
-      </p:sp>
-      <p:sp>
-        <p:nvSpPr>
-          <p:cNvPr id="4" name="Slide Number Placeholder 3"/>
-          <p:cNvSpPr>
-            <a:spLocks noGrp="1"/>
-          </p:cNvSpPr>
-          <p:nvPr>
-            <p:ph type="sldNum" sz="quarter" idx="5"/>
-          </p:nvPr>
-        </p:nvSpPr>
-        <p:spPr/>
-        <p:txBody>
-          <a:bodyPr/>
-          <a:lstStyle/>
-          <a:p>
-            <a:fld id="{60978604-55B0-5242-B3ED-8E8E0F5DD214}" type="slidenum">
-              <a:rPr lang="en-US" smtClean="0"/>
-              <a:t>3</a:t>
-            </a:fld>
-            <a:endParaRPr lang="en-US"/>
-          </a:p>
-        </p:txBody>
-      </p:sp>
-    </p:spTree>
-    <p:extLst>
-      <p:ext uri="{BB962C8B-B14F-4D97-AF65-F5344CB8AC3E}">
-        <p14:creationId xmlns:p14="http://schemas.microsoft.com/office/powerpoint/2010/main" val="3048864477"/>
-      </p:ext>
-    </p:extLst>
-  </p:cSld>
-  <p:clrMapOvr>
-    <a:masterClrMapping/>
-  </p:clrMapOvr>
-</p:notes>
-</file>
-
-<file path=ppt/notesSlides/notesSlide30.xml><?xml version="1.0" encoding="utf-8"?>
+<file path=ppt/notesSlides/notesSlide31.xml><?xml version="1.0" encoding="utf-8"?>
 <p:notes xmlns:a="http://schemas.openxmlformats.org/drawingml/2006/main" xmlns:r="http://schemas.openxmlformats.org/officeDocument/2006/relationships" xmlns:p="http://schemas.openxmlformats.org/presentationml/2006/main">
   <p:cSld>
     <p:spTree>
@@ -3288,7 +3438,7 @@
           <a:p>
             <a:fld id="{AC44E78C-583C-4D47-AA52-A4329031AEEE}" type="slidenum">
               <a:rPr lang="en-US" smtClean="0"/>
-              <a:t>32</a:t>
+              <a:t>33</a:t>
             </a:fld>
             <a:endParaRPr lang="en-US"/>
           </a:p>
@@ -3307,7 +3457,7 @@
 </p:notes>
 </file>
 
-<file path=ppt/notesSlides/notesSlide31.xml><?xml version="1.0" encoding="utf-8"?>
+<file path=ppt/notesSlides/notesSlide32.xml><?xml version="1.0" encoding="utf-8"?>
 <p:notes xmlns:a="http://schemas.openxmlformats.org/drawingml/2006/main" xmlns:r="http://schemas.openxmlformats.org/officeDocument/2006/relationships" xmlns:p="http://schemas.openxmlformats.org/presentationml/2006/main">
   <p:cSld>
     <p:spTree>
@@ -3432,7 +3582,7 @@
           <a:p>
             <a:fld id="{AC44E78C-583C-4D47-AA52-A4329031AEEE}" type="slidenum">
               <a:rPr lang="en-US" smtClean="0"/>
-              <a:t>33</a:t>
+              <a:t>34</a:t>
             </a:fld>
             <a:endParaRPr lang="en-US"/>
           </a:p>
@@ -3451,7 +3601,7 @@
 </p:notes>
 </file>
 
-<file path=ppt/notesSlides/notesSlide32.xml><?xml version="1.0" encoding="utf-8"?>
+<file path=ppt/notesSlides/notesSlide33.xml><?xml version="1.0" encoding="utf-8"?>
 <p:notes xmlns:a="http://schemas.openxmlformats.org/drawingml/2006/main" xmlns:r="http://schemas.openxmlformats.org/officeDocument/2006/relationships" xmlns:p="http://schemas.openxmlformats.org/presentationml/2006/main">
   <p:cSld>
     <p:spTree>
@@ -3516,7 +3666,7 @@
           <a:p>
             <a:fld id="{AC44E78C-583C-4D47-AA52-A4329031AEEE}" type="slidenum">
               <a:rPr lang="en-US" smtClean="0"/>
-              <a:t>34</a:t>
+              <a:t>35</a:t>
             </a:fld>
             <a:endParaRPr lang="en-US"/>
           </a:p>
@@ -3535,7 +3685,7 @@
 </p:notes>
 </file>
 
-<file path=ppt/notesSlides/notesSlide33.xml><?xml version="1.0" encoding="utf-8"?>
+<file path=ppt/notesSlides/notesSlide34.xml><?xml version="1.0" encoding="utf-8"?>
 <p:notes xmlns:a="http://schemas.openxmlformats.org/drawingml/2006/main" xmlns:r="http://schemas.openxmlformats.org/officeDocument/2006/relationships" xmlns:p="http://schemas.openxmlformats.org/presentationml/2006/main">
   <p:cSld>
     <p:spTree>
@@ -3624,7 +3774,7 @@
           <a:p>
             <a:fld id="{AC44E78C-583C-4D47-AA52-A4329031AEEE}" type="slidenum">
               <a:rPr lang="en-US" smtClean="0"/>
-              <a:t>35</a:t>
+              <a:t>36</a:t>
             </a:fld>
             <a:endParaRPr lang="en-US"/>
           </a:p>
@@ -3643,7 +3793,7 @@
 </p:notes>
 </file>
 
-<file path=ppt/notesSlides/notesSlide34.xml><?xml version="1.0" encoding="utf-8"?>
+<file path=ppt/notesSlides/notesSlide35.xml><?xml version="1.0" encoding="utf-8"?>
 <p:notes xmlns:a="http://schemas.openxmlformats.org/drawingml/2006/main" xmlns:r="http://schemas.openxmlformats.org/officeDocument/2006/relationships" xmlns:p="http://schemas.openxmlformats.org/presentationml/2006/main">
   <p:cSld>
     <p:spTree>
@@ -3708,7 +3858,7 @@
           <a:p>
             <a:fld id="{AC44E78C-583C-4D47-AA52-A4329031AEEE}" type="slidenum">
               <a:rPr lang="en-US" smtClean="0"/>
-              <a:t>36</a:t>
+              <a:t>37</a:t>
             </a:fld>
             <a:endParaRPr lang="en-US"/>
           </a:p>
@@ -3727,7 +3877,7 @@
 </p:notes>
 </file>
 
-<file path=ppt/notesSlides/notesSlide35.xml><?xml version="1.0" encoding="utf-8"?>
+<file path=ppt/notesSlides/notesSlide36.xml><?xml version="1.0" encoding="utf-8"?>
 <p:notes xmlns:a="http://schemas.openxmlformats.org/drawingml/2006/main" xmlns:r="http://schemas.openxmlformats.org/officeDocument/2006/relationships" xmlns:p="http://schemas.openxmlformats.org/presentationml/2006/main">
   <p:cSld>
     <p:spTree>
@@ -3816,7 +3966,7 @@
           <a:p>
             <a:fld id="{AC44E78C-583C-4D47-AA52-A4329031AEEE}" type="slidenum">
               <a:rPr lang="en-US" smtClean="0"/>
-              <a:t>37</a:t>
+              <a:t>38</a:t>
             </a:fld>
             <a:endParaRPr lang="en-US"/>
           </a:p>
@@ -3835,7 +3985,7 @@
 </p:notes>
 </file>
 
-<file path=ppt/notesSlides/notesSlide36.xml><?xml version="1.0" encoding="utf-8"?>
+<file path=ppt/notesSlides/notesSlide37.xml><?xml version="1.0" encoding="utf-8"?>
 <p:notes xmlns:a="http://schemas.openxmlformats.org/drawingml/2006/main" xmlns:r="http://schemas.openxmlformats.org/officeDocument/2006/relationships" xmlns:p="http://schemas.openxmlformats.org/presentationml/2006/main">
   <p:cSld>
     <p:spTree>
@@ -3900,7 +4050,7 @@
           <a:p>
             <a:fld id="{AC44E78C-583C-4D47-AA52-A4329031AEEE}" type="slidenum">
               <a:rPr lang="en-US" smtClean="0"/>
-              <a:t>38</a:t>
+              <a:t>39</a:t>
             </a:fld>
             <a:endParaRPr lang="en-US"/>
           </a:p>
@@ -3919,7 +4069,7 @@
 </p:notes>
 </file>
 
-<file path=ppt/notesSlides/notesSlide37.xml><?xml version="1.0" encoding="utf-8"?>
+<file path=ppt/notesSlides/notesSlide38.xml><?xml version="1.0" encoding="utf-8"?>
 <p:notes xmlns:a="http://schemas.openxmlformats.org/drawingml/2006/main" xmlns:r="http://schemas.openxmlformats.org/officeDocument/2006/relationships" xmlns:p="http://schemas.openxmlformats.org/presentationml/2006/main">
   <p:cSld>
     <p:spTree>
@@ -4008,7 +4158,7 @@
           <a:p>
             <a:fld id="{AC44E78C-583C-4D47-AA52-A4329031AEEE}" type="slidenum">
               <a:rPr lang="en-US" smtClean="0"/>
-              <a:t>39</a:t>
+              <a:t>40</a:t>
             </a:fld>
             <a:endParaRPr lang="en-US"/>
           </a:p>
@@ -4028,6 +4178,105 @@
 </file>
 
 <file path=ppt/notesSlides/notesSlide4.xml><?xml version="1.0" encoding="utf-8"?>
+<p:notes xmlns:a="http://schemas.openxmlformats.org/drawingml/2006/main" xmlns:r="http://schemas.openxmlformats.org/officeDocument/2006/relationships" xmlns:p="http://schemas.openxmlformats.org/presentationml/2006/main">
+  <p:cSld>
+    <p:spTree>
+      <p:nvGrpSpPr>
+        <p:cNvPr id="1" name=""/>
+        <p:cNvGrpSpPr/>
+        <p:nvPr/>
+      </p:nvGrpSpPr>
+      <p:grpSpPr>
+        <a:xfrm>
+          <a:off x="0" y="0"/>
+          <a:ext cx="0" cy="0"/>
+          <a:chOff x="0" y="0"/>
+          <a:chExt cx="0" cy="0"/>
+        </a:xfrm>
+      </p:grpSpPr>
+      <p:sp>
+        <p:nvSpPr>
+          <p:cNvPr id="2" name="Slide Image Placeholder 1"/>
+          <p:cNvSpPr>
+            <a:spLocks noGrp="1" noRot="1" noChangeAspect="1"/>
+          </p:cNvSpPr>
+          <p:nvPr>
+            <p:ph type="sldImg"/>
+          </p:nvPr>
+        </p:nvSpPr>
+        <p:spPr/>
+      </p:sp>
+      <p:sp>
+        <p:nvSpPr>
+          <p:cNvPr id="3" name="Notes Placeholder 2"/>
+          <p:cNvSpPr>
+            <a:spLocks noGrp="1"/>
+          </p:cNvSpPr>
+          <p:nvPr>
+            <p:ph type="body" idx="1"/>
+          </p:nvPr>
+        </p:nvSpPr>
+        <p:spPr/>
+        <p:txBody>
+          <a:bodyPr/>
+          <a:lstStyle/>
+          <a:p>
+            <a:r>
+              <a:rPr lang="en-US" dirty="0"/>
+              <a:t>SLURM – Simple Linux Utility for Resource Management.</a:t>
+            </a:r>
+          </a:p>
+          <a:p>
+            <a:r>
+              <a:rPr lang="en-US" dirty="0"/>
+              <a:t>The software we use to run our HPC.</a:t>
+            </a:r>
+          </a:p>
+          <a:p>
+            <a:r>
+              <a:rPr lang="en-US" dirty="0"/>
+              <a:t>This is one reason why you need to be competent Unix users!</a:t>
+            </a:r>
+          </a:p>
+        </p:txBody>
+      </p:sp>
+      <p:sp>
+        <p:nvSpPr>
+          <p:cNvPr id="4" name="Slide Number Placeholder 3"/>
+          <p:cNvSpPr>
+            <a:spLocks noGrp="1"/>
+          </p:cNvSpPr>
+          <p:nvPr>
+            <p:ph type="sldNum" sz="quarter" idx="5"/>
+          </p:nvPr>
+        </p:nvSpPr>
+        <p:spPr/>
+        <p:txBody>
+          <a:bodyPr/>
+          <a:lstStyle/>
+          <a:p>
+            <a:fld id="{60978604-55B0-5242-B3ED-8E8E0F5DD214}" type="slidenum">
+              <a:rPr lang="en-US" smtClean="0"/>
+              <a:t>4</a:t>
+            </a:fld>
+            <a:endParaRPr lang="en-US"/>
+          </a:p>
+        </p:txBody>
+      </p:sp>
+    </p:spTree>
+    <p:extLst>
+      <p:ext uri="{BB962C8B-B14F-4D97-AF65-F5344CB8AC3E}">
+        <p14:creationId xmlns:p14="http://schemas.microsoft.com/office/powerpoint/2010/main" val="3048864477"/>
+      </p:ext>
+    </p:extLst>
+  </p:cSld>
+  <p:clrMapOvr>
+    <a:masterClrMapping/>
+  </p:clrMapOvr>
+</p:notes>
+</file>
+
+<file path=ppt/notesSlides/notesSlide5.xml><?xml version="1.0" encoding="utf-8"?>
 <p:notes xmlns:a="http://schemas.openxmlformats.org/drawingml/2006/main" xmlns:r="http://schemas.openxmlformats.org/officeDocument/2006/relationships" xmlns:p="http://schemas.openxmlformats.org/presentationml/2006/main">
   <p:cSld>
     <p:spTree>
@@ -4116,7 +4365,7 @@
           <a:p>
             <a:fld id="{AC44E78C-583C-4D47-AA52-A4329031AEEE}" type="slidenum">
               <a:rPr lang="en-US" smtClean="0"/>
-              <a:t>4</a:t>
+              <a:t>5</a:t>
             </a:fld>
             <a:endParaRPr lang="en-US"/>
           </a:p>
@@ -4135,7 +4384,7 @@
 </p:notes>
 </file>
 
-<file path=ppt/notesSlides/notesSlide5.xml><?xml version="1.0" encoding="utf-8"?>
+<file path=ppt/notesSlides/notesSlide6.xml><?xml version="1.0" encoding="utf-8"?>
 <p:notes xmlns:a="http://schemas.openxmlformats.org/drawingml/2006/main" xmlns:r="http://schemas.openxmlformats.org/officeDocument/2006/relationships" xmlns:p="http://schemas.openxmlformats.org/presentationml/2006/main">
   <p:cSld>
     <p:spTree>
@@ -4200,7 +4449,7 @@
           <a:p>
             <a:fld id="{AC44E78C-583C-4D47-AA52-A4329031AEEE}" type="slidenum">
               <a:rPr lang="en-US" smtClean="0"/>
-              <a:t>5</a:t>
+              <a:t>6</a:t>
             </a:fld>
             <a:endParaRPr lang="en-US"/>
           </a:p>
@@ -4219,7 +4468,7 @@
 </p:notes>
 </file>
 
-<file path=ppt/notesSlides/notesSlide6.xml><?xml version="1.0" encoding="utf-8"?>
+<file path=ppt/notesSlides/notesSlide7.xml><?xml version="1.0" encoding="utf-8"?>
 <p:notes xmlns:a="http://schemas.openxmlformats.org/drawingml/2006/main" xmlns:r="http://schemas.openxmlformats.org/officeDocument/2006/relationships" xmlns:p="http://schemas.openxmlformats.org/presentationml/2006/main">
   <p:cSld>
     <p:spTree>
@@ -4308,7 +4557,7 @@
           <a:p>
             <a:fld id="{AC44E78C-583C-4D47-AA52-A4329031AEEE}" type="slidenum">
               <a:rPr lang="en-US" smtClean="0"/>
-              <a:t>6</a:t>
+              <a:t>7</a:t>
             </a:fld>
             <a:endParaRPr lang="en-US"/>
           </a:p>
@@ -4327,7 +4576,7 @@
 </p:notes>
 </file>
 
-<file path=ppt/notesSlides/notesSlide7.xml><?xml version="1.0" encoding="utf-8"?>
+<file path=ppt/notesSlides/notesSlide8.xml><?xml version="1.0" encoding="utf-8"?>
 <p:notes xmlns:a="http://schemas.openxmlformats.org/drawingml/2006/main" xmlns:r="http://schemas.openxmlformats.org/officeDocument/2006/relationships" xmlns:p="http://schemas.openxmlformats.org/presentationml/2006/main">
   <p:cSld>
     <p:spTree>
@@ -4416,7 +4665,7 @@
           <a:p>
             <a:fld id="{AC44E78C-583C-4D47-AA52-A4329031AEEE}" type="slidenum">
               <a:rPr lang="en-US" smtClean="0"/>
-              <a:t>7</a:t>
+              <a:t>8</a:t>
             </a:fld>
             <a:endParaRPr lang="en-US"/>
           </a:p>
@@ -4435,7 +4684,7 @@
 </p:notes>
 </file>
 
-<file path=ppt/notesSlides/notesSlide8.xml><?xml version="1.0" encoding="utf-8"?>
+<file path=ppt/notesSlides/notesSlide9.xml><?xml version="1.0" encoding="utf-8"?>
 <p:notes xmlns:a="http://schemas.openxmlformats.org/drawingml/2006/main" xmlns:r="http://schemas.openxmlformats.org/officeDocument/2006/relationships" xmlns:p="http://schemas.openxmlformats.org/presentationml/2006/main">
   <p:cSld>
     <p:spTree>
@@ -4524,7 +4773,7 @@
           <a:p>
             <a:fld id="{AC44E78C-583C-4D47-AA52-A4329031AEEE}" type="slidenum">
               <a:rPr lang="en-US" smtClean="0"/>
-              <a:t>8</a:t>
+              <a:t>9</a:t>
             </a:fld>
             <a:endParaRPr lang="en-US"/>
           </a:p>
@@ -4534,114 +4783,6 @@
     <p:extLst>
       <p:ext uri="{BB962C8B-B14F-4D97-AF65-F5344CB8AC3E}">
         <p14:creationId xmlns:p14="http://schemas.microsoft.com/office/powerpoint/2010/main" val="1592579340"/>
-      </p:ext>
-    </p:extLst>
-  </p:cSld>
-  <p:clrMapOvr>
-    <a:masterClrMapping/>
-  </p:clrMapOvr>
-</p:notes>
-</file>
-
-<file path=ppt/notesSlides/notesSlide9.xml><?xml version="1.0" encoding="utf-8"?>
-<p:notes xmlns:a="http://schemas.openxmlformats.org/drawingml/2006/main" xmlns:r="http://schemas.openxmlformats.org/officeDocument/2006/relationships" xmlns:p="http://schemas.openxmlformats.org/presentationml/2006/main">
-  <p:cSld>
-    <p:spTree>
-      <p:nvGrpSpPr>
-        <p:cNvPr id="1" name="">
-          <a:extLst>
-            <a:ext uri="{FF2B5EF4-FFF2-40B4-BE49-F238E27FC236}">
-              <a16:creationId xmlns:a16="http://schemas.microsoft.com/office/drawing/2014/main" id="{79017030-0C6A-30FA-9FD9-DF51D0CB2F57}"/>
-            </a:ext>
-          </a:extLst>
-        </p:cNvPr>
-        <p:cNvGrpSpPr/>
-        <p:nvPr/>
-      </p:nvGrpSpPr>
-      <p:grpSpPr>
-        <a:xfrm>
-          <a:off x="0" y="0"/>
-          <a:ext cx="0" cy="0"/>
-          <a:chOff x="0" y="0"/>
-          <a:chExt cx="0" cy="0"/>
-        </a:xfrm>
-      </p:grpSpPr>
-      <p:sp>
-        <p:nvSpPr>
-          <p:cNvPr id="2" name="Slide Image Placeholder 1">
-            <a:extLst>
-              <a:ext uri="{FF2B5EF4-FFF2-40B4-BE49-F238E27FC236}">
-                <a16:creationId xmlns:a16="http://schemas.microsoft.com/office/drawing/2014/main" id="{6318BE7F-97A1-16CB-4A8B-2FA9481F1F64}"/>
-              </a:ext>
-            </a:extLst>
-          </p:cNvPr>
-          <p:cNvSpPr>
-            <a:spLocks noGrp="1" noRot="1" noChangeAspect="1"/>
-          </p:cNvSpPr>
-          <p:nvPr>
-            <p:ph type="sldImg"/>
-          </p:nvPr>
-        </p:nvSpPr>
-        <p:spPr/>
-      </p:sp>
-      <p:sp>
-        <p:nvSpPr>
-          <p:cNvPr id="3" name="Notes Placeholder 2">
-            <a:extLst>
-              <a:ext uri="{FF2B5EF4-FFF2-40B4-BE49-F238E27FC236}">
-                <a16:creationId xmlns:a16="http://schemas.microsoft.com/office/drawing/2014/main" id="{FE333B5C-883A-C796-A8F4-7B7BC029622B}"/>
-              </a:ext>
-            </a:extLst>
-          </p:cNvPr>
-          <p:cNvSpPr>
-            <a:spLocks noGrp="1"/>
-          </p:cNvSpPr>
-          <p:nvPr>
-            <p:ph type="body" idx="1"/>
-          </p:nvPr>
-        </p:nvSpPr>
-        <p:spPr/>
-        <p:txBody>
-          <a:bodyPr/>
-          <a:lstStyle/>
-          <a:p>
-            <a:endParaRPr lang="en-US" dirty="0"/>
-          </a:p>
-        </p:txBody>
-      </p:sp>
-      <p:sp>
-        <p:nvSpPr>
-          <p:cNvPr id="4" name="Slide Number Placeholder 3">
-            <a:extLst>
-              <a:ext uri="{FF2B5EF4-FFF2-40B4-BE49-F238E27FC236}">
-                <a16:creationId xmlns:a16="http://schemas.microsoft.com/office/drawing/2014/main" id="{96FB3AE2-B72C-BC08-0F6B-75CACE072B0D}"/>
-              </a:ext>
-            </a:extLst>
-          </p:cNvPr>
-          <p:cNvSpPr>
-            <a:spLocks noGrp="1"/>
-          </p:cNvSpPr>
-          <p:nvPr>
-            <p:ph type="sldNum" sz="quarter" idx="5"/>
-          </p:nvPr>
-        </p:nvSpPr>
-        <p:spPr/>
-        <p:txBody>
-          <a:bodyPr/>
-          <a:lstStyle/>
-          <a:p>
-            <a:fld id="{AC44E78C-583C-4D47-AA52-A4329031AEEE}" type="slidenum">
-              <a:rPr lang="en-US" smtClean="0"/>
-              <a:t>9</a:t>
-            </a:fld>
-            <a:endParaRPr lang="en-US"/>
-          </a:p>
-        </p:txBody>
-      </p:sp>
-    </p:spTree>
-    <p:extLst>
-      <p:ext uri="{BB962C8B-B14F-4D97-AF65-F5344CB8AC3E}">
-        <p14:creationId xmlns:p14="http://schemas.microsoft.com/office/powerpoint/2010/main" val="370350663"/>
       </p:ext>
     </p:extLst>
   </p:cSld>
@@ -4800,7 +4941,7 @@
           <a:p>
             <a:fld id="{B70B061E-8F2F-D342-BB88-8B219BD1F6BB}" type="datetimeFigureOut">
               <a:rPr lang="en-US" smtClean="0"/>
-              <a:t>10/6/25</a:t>
+              <a:t>10/9/25</a:t>
             </a:fld>
             <a:endParaRPr lang="en-US"/>
           </a:p>
@@ -5000,7 +5141,7 @@
           <a:p>
             <a:fld id="{B70B061E-8F2F-D342-BB88-8B219BD1F6BB}" type="datetimeFigureOut">
               <a:rPr lang="en-US" smtClean="0"/>
-              <a:t>10/6/25</a:t>
+              <a:t>10/9/25</a:t>
             </a:fld>
             <a:endParaRPr lang="en-US"/>
           </a:p>
@@ -5210,7 +5351,7 @@
           <a:p>
             <a:fld id="{B70B061E-8F2F-D342-BB88-8B219BD1F6BB}" type="datetimeFigureOut">
               <a:rPr lang="en-US" smtClean="0"/>
-              <a:t>10/6/25</a:t>
+              <a:t>10/9/25</a:t>
             </a:fld>
             <a:endParaRPr lang="en-US"/>
           </a:p>
@@ -5410,7 +5551,7 @@
           <a:p>
             <a:fld id="{B70B061E-8F2F-D342-BB88-8B219BD1F6BB}" type="datetimeFigureOut">
               <a:rPr lang="en-US" smtClean="0"/>
-              <a:t>10/6/25</a:t>
+              <a:t>10/9/25</a:t>
             </a:fld>
             <a:endParaRPr lang="en-US"/>
           </a:p>
@@ -5686,7 +5827,7 @@
           <a:p>
             <a:fld id="{B70B061E-8F2F-D342-BB88-8B219BD1F6BB}" type="datetimeFigureOut">
               <a:rPr lang="en-US" smtClean="0"/>
-              <a:t>10/6/25</a:t>
+              <a:t>10/9/25</a:t>
             </a:fld>
             <a:endParaRPr lang="en-US"/>
           </a:p>
@@ -5954,7 +6095,7 @@
           <a:p>
             <a:fld id="{B70B061E-8F2F-D342-BB88-8B219BD1F6BB}" type="datetimeFigureOut">
               <a:rPr lang="en-US" smtClean="0"/>
-              <a:t>10/6/25</a:t>
+              <a:t>10/9/25</a:t>
             </a:fld>
             <a:endParaRPr lang="en-US"/>
           </a:p>
@@ -6369,7 +6510,7 @@
           <a:p>
             <a:fld id="{B70B061E-8F2F-D342-BB88-8B219BD1F6BB}" type="datetimeFigureOut">
               <a:rPr lang="en-US" smtClean="0"/>
-              <a:t>10/6/25</a:t>
+              <a:t>10/9/25</a:t>
             </a:fld>
             <a:endParaRPr lang="en-US"/>
           </a:p>
@@ -6511,7 +6652,7 @@
           <a:p>
             <a:fld id="{B70B061E-8F2F-D342-BB88-8B219BD1F6BB}" type="datetimeFigureOut">
               <a:rPr lang="en-US" smtClean="0"/>
-              <a:t>10/6/25</a:t>
+              <a:t>10/9/25</a:t>
             </a:fld>
             <a:endParaRPr lang="en-US"/>
           </a:p>
@@ -6624,7 +6765,7 @@
           <a:p>
             <a:fld id="{B70B061E-8F2F-D342-BB88-8B219BD1F6BB}" type="datetimeFigureOut">
               <a:rPr lang="en-US" smtClean="0"/>
-              <a:t>10/6/25</a:t>
+              <a:t>10/9/25</a:t>
             </a:fld>
             <a:endParaRPr lang="en-US"/>
           </a:p>
@@ -6937,7 +7078,7 @@
           <a:p>
             <a:fld id="{B70B061E-8F2F-D342-BB88-8B219BD1F6BB}" type="datetimeFigureOut">
               <a:rPr lang="en-US" smtClean="0"/>
-              <a:t>10/6/25</a:t>
+              <a:t>10/9/25</a:t>
             </a:fld>
             <a:endParaRPr lang="en-US"/>
           </a:p>
@@ -7226,7 +7367,7 @@
           <a:p>
             <a:fld id="{B70B061E-8F2F-D342-BB88-8B219BD1F6BB}" type="datetimeFigureOut">
               <a:rPr lang="en-US" smtClean="0"/>
-              <a:t>10/6/25</a:t>
+              <a:t>10/9/25</a:t>
             </a:fld>
             <a:endParaRPr lang="en-US"/>
           </a:p>
@@ -7469,7 +7610,7 @@
           <a:p>
             <a:fld id="{B70B061E-8F2F-D342-BB88-8B219BD1F6BB}" type="datetimeFigureOut">
               <a:rPr lang="en-US" smtClean="0"/>
-              <a:t>10/6/25</a:t>
+              <a:t>10/9/25</a:t>
             </a:fld>
             <a:endParaRPr lang="en-US"/>
           </a:p>
@@ -8350,6 +8491,498 @@
         <p:cNvPr id="1" name="">
           <a:extLst>
             <a:ext uri="{FF2B5EF4-FFF2-40B4-BE49-F238E27FC236}">
+              <a16:creationId xmlns:a16="http://schemas.microsoft.com/office/drawing/2014/main" id="{848074D2-25CE-7AA7-BBF0-2C11EF753D11}"/>
+            </a:ext>
+          </a:extLst>
+        </p:cNvPr>
+        <p:cNvGrpSpPr/>
+        <p:nvPr/>
+      </p:nvGrpSpPr>
+      <p:grpSpPr>
+        <a:xfrm>
+          <a:off x="0" y="0"/>
+          <a:ext cx="0" cy="0"/>
+          <a:chOff x="0" y="0"/>
+          <a:chExt cx="0" cy="0"/>
+        </a:xfrm>
+      </p:grpSpPr>
+      <p:sp>
+        <p:nvSpPr>
+          <p:cNvPr id="2" name="Title 1">
+            <a:extLst>
+              <a:ext uri="{FF2B5EF4-FFF2-40B4-BE49-F238E27FC236}">
+                <a16:creationId xmlns:a16="http://schemas.microsoft.com/office/drawing/2014/main" id="{DCFB93B0-6835-5C78-E7E2-252E13977148}"/>
+              </a:ext>
+            </a:extLst>
+          </p:cNvPr>
+          <p:cNvSpPr>
+            <a:spLocks noGrp="1"/>
+          </p:cNvSpPr>
+          <p:nvPr>
+            <p:ph type="ctrTitle"/>
+          </p:nvPr>
+        </p:nvSpPr>
+        <p:spPr>
+          <a:xfrm>
+            <a:off x="1524000" y="204143"/>
+            <a:ext cx="9144000" cy="557441"/>
+          </a:xfrm>
+        </p:spPr>
+        <p:txBody>
+          <a:bodyPr>
+            <a:normAutofit fontScale="90000"/>
+          </a:bodyPr>
+          <a:lstStyle/>
+          <a:p>
+            <a:r>
+              <a:rPr lang="en-US" sz="3600" dirty="0"/>
+              <a:t>Every job needs a job submission script:</a:t>
+            </a:r>
+          </a:p>
+        </p:txBody>
+      </p:sp>
+      <p:sp>
+        <p:nvSpPr>
+          <p:cNvPr id="5" name="TextBox 4">
+            <a:extLst>
+              <a:ext uri="{FF2B5EF4-FFF2-40B4-BE49-F238E27FC236}">
+                <a16:creationId xmlns:a16="http://schemas.microsoft.com/office/drawing/2014/main" id="{0FAB5DF2-474C-68E4-24AA-826CDEEDF0EB}"/>
+              </a:ext>
+            </a:extLst>
+          </p:cNvPr>
+          <p:cNvSpPr txBox="1"/>
+          <p:nvPr/>
+        </p:nvSpPr>
+        <p:spPr>
+          <a:xfrm>
+            <a:off x="464652" y="1343888"/>
+            <a:ext cx="6504183" cy="4801314"/>
+          </a:xfrm>
+          <a:prstGeom prst="rect">
+            <a:avLst/>
+          </a:prstGeom>
+          <a:solidFill>
+            <a:schemeClr val="accent1">
+              <a:alpha val="16000"/>
+            </a:schemeClr>
+          </a:solidFill>
+          <a:ln>
+            <a:solidFill>
+              <a:schemeClr val="accent1"/>
+            </a:solidFill>
+          </a:ln>
+        </p:spPr>
+        <p:txBody>
+          <a:bodyPr wrap="square">
+            <a:spAutoFit/>
+          </a:bodyPr>
+          <a:lstStyle/>
+          <a:p>
+            <a:r>
+              <a:rPr lang="en-US" dirty="0"/>
+              <a:t>#!/bin/bash</a:t>
+            </a:r>
+          </a:p>
+          <a:p>
+            <a:endParaRPr lang="en-US" dirty="0"/>
+          </a:p>
+          <a:p>
+            <a:r>
+              <a:rPr lang="en-US" dirty="0"/>
+              <a:t>#SBATCH --partition=</a:t>
+            </a:r>
+            <a:r>
+              <a:rPr lang="en-US" dirty="0" err="1"/>
+              <a:t>defq</a:t>
+            </a:r>
+            <a:endParaRPr lang="en-US" dirty="0"/>
+          </a:p>
+          <a:p>
+            <a:r>
+              <a:rPr lang="en-US" dirty="0"/>
+              <a:t>#SBATCH --nodes=1</a:t>
+            </a:r>
+          </a:p>
+          <a:p>
+            <a:r>
+              <a:rPr lang="en-US" dirty="0"/>
+              <a:t>#SBATCH --</a:t>
+            </a:r>
+            <a:r>
+              <a:rPr lang="en-US" dirty="0" err="1"/>
+              <a:t>ntasks</a:t>
+            </a:r>
+            <a:r>
+              <a:rPr lang="en-US" dirty="0"/>
+              <a:t>=1</a:t>
+            </a:r>
+          </a:p>
+          <a:p>
+            <a:r>
+              <a:rPr lang="en-US" dirty="0"/>
+              <a:t>#SBATCH --</a:t>
+            </a:r>
+            <a:r>
+              <a:rPr lang="en-US" dirty="0" err="1"/>
+              <a:t>cpus</a:t>
+            </a:r>
+            <a:r>
+              <a:rPr lang="en-US" dirty="0"/>
+              <a:t>-per-task=8</a:t>
+            </a:r>
+          </a:p>
+          <a:p>
+            <a:r>
+              <a:rPr lang="en-US" dirty="0"/>
+              <a:t>#SBATCH --mem=5g</a:t>
+            </a:r>
+          </a:p>
+          <a:p>
+            <a:r>
+              <a:rPr lang="en-US" dirty="0"/>
+              <a:t>#SBATCH --time=00:10:00</a:t>
+            </a:r>
+          </a:p>
+          <a:p>
+            <a:r>
+              <a:rPr lang="en-US" dirty="0"/>
+              <a:t>#SBATCH --job-name=</a:t>
+            </a:r>
+            <a:r>
+              <a:rPr lang="en-US" dirty="0" err="1"/>
+              <a:t>my_job</a:t>
+            </a:r>
+            <a:endParaRPr lang="en-US" dirty="0"/>
+          </a:p>
+          <a:p>
+            <a:r>
+              <a:rPr lang="en-US" dirty="0"/>
+              <a:t>#SBATCH --output=/gpfs01/home/</a:t>
+            </a:r>
+            <a:r>
+              <a:rPr lang="en-US" dirty="0" err="1">
+                <a:solidFill>
+                  <a:schemeClr val="accent6">
+                    <a:lumMod val="75000"/>
+                  </a:schemeClr>
+                </a:solidFill>
+              </a:rPr>
+              <a:t>mbzlld</a:t>
+            </a:r>
+            <a:r>
+              <a:rPr lang="en-US" dirty="0"/>
+              <a:t>/</a:t>
+            </a:r>
+            <a:r>
+              <a:rPr lang="en-US" dirty="0" err="1"/>
+              <a:t>slurm</a:t>
+            </a:r>
+            <a:r>
+              <a:rPr lang="en-US" dirty="0"/>
+              <a:t>-%x-%</a:t>
+            </a:r>
+            <a:r>
+              <a:rPr lang="en-US" dirty="0" err="1"/>
+              <a:t>j.out</a:t>
+            </a:r>
+            <a:endParaRPr lang="en-US" dirty="0"/>
+          </a:p>
+          <a:p>
+            <a:r>
+              <a:rPr lang="en-US" dirty="0"/>
+              <a:t>#SBATCH --error=/gpfs01/home/</a:t>
+            </a:r>
+            <a:r>
+              <a:rPr lang="en-US" dirty="0" err="1">
+                <a:solidFill>
+                  <a:schemeClr val="accent6">
+                    <a:lumMod val="75000"/>
+                  </a:schemeClr>
+                </a:solidFill>
+              </a:rPr>
+              <a:t>mbzlld</a:t>
+            </a:r>
+            <a:r>
+              <a:rPr lang="en-US" dirty="0"/>
+              <a:t>/</a:t>
+            </a:r>
+            <a:r>
+              <a:rPr lang="en-US" dirty="0" err="1"/>
+              <a:t>slurm</a:t>
+            </a:r>
+            <a:r>
+              <a:rPr lang="en-US" dirty="0"/>
+              <a:t>-%x-%</a:t>
+            </a:r>
+            <a:r>
+              <a:rPr lang="en-US" dirty="0" err="1"/>
+              <a:t>j.err</a:t>
+            </a:r>
+            <a:endParaRPr lang="en-US" dirty="0"/>
+          </a:p>
+          <a:p>
+            <a:r>
+              <a:rPr lang="en-US" dirty="0"/>
+              <a:t>#SBATCH --mail-type=ALL</a:t>
+            </a:r>
+          </a:p>
+          <a:p>
+            <a:r>
+              <a:rPr lang="en-US" dirty="0"/>
+              <a:t>#SBATCH --mail-user=</a:t>
+            </a:r>
+            <a:r>
+              <a:rPr lang="en-US" dirty="0" err="1">
+                <a:solidFill>
+                  <a:schemeClr val="accent6">
+                    <a:lumMod val="75000"/>
+                  </a:schemeClr>
+                </a:solidFill>
+              </a:rPr>
+              <a:t>mbzlld</a:t>
+            </a:r>
+            <a:r>
+              <a:rPr lang="en-US" dirty="0" err="1"/>
+              <a:t>@exmail.nottingham.ac.uk</a:t>
+            </a:r>
+            <a:endParaRPr lang="en-US" dirty="0"/>
+          </a:p>
+          <a:p>
+            <a:endParaRPr lang="en-US" dirty="0"/>
+          </a:p>
+          <a:p>
+            <a:r>
+              <a:rPr lang="en-US" dirty="0"/>
+              <a:t># Write out a test file to check our job ran</a:t>
+            </a:r>
+          </a:p>
+          <a:p>
+            <a:r>
+              <a:rPr lang="en-US" dirty="0"/>
+              <a:t>echo “hello world” &gt; ~/</a:t>
+            </a:r>
+            <a:r>
+              <a:rPr lang="en-US" dirty="0" err="1"/>
+              <a:t>our_test_output.txt</a:t>
+            </a:r>
+            <a:endParaRPr lang="en-US" dirty="0"/>
+          </a:p>
+          <a:p>
+            <a:endParaRPr lang="en-US" dirty="0"/>
+          </a:p>
+        </p:txBody>
+      </p:sp>
+      <p:sp>
+        <p:nvSpPr>
+          <p:cNvPr id="7" name="TextBox 6">
+            <a:extLst>
+              <a:ext uri="{FF2B5EF4-FFF2-40B4-BE49-F238E27FC236}">
+                <a16:creationId xmlns:a16="http://schemas.microsoft.com/office/drawing/2014/main" id="{8675C216-BDE8-1459-37E9-65D06D5F2075}"/>
+              </a:ext>
+            </a:extLst>
+          </p:cNvPr>
+          <p:cNvSpPr txBox="1"/>
+          <p:nvPr/>
+        </p:nvSpPr>
+        <p:spPr>
+          <a:xfrm>
+            <a:off x="430009" y="923142"/>
+            <a:ext cx="3286734" cy="369332"/>
+          </a:xfrm>
+          <a:prstGeom prst="rect">
+            <a:avLst/>
+          </a:prstGeom>
+          <a:noFill/>
+        </p:spPr>
+        <p:txBody>
+          <a:bodyPr wrap="none" rtlCol="0">
+            <a:spAutoFit/>
+          </a:bodyPr>
+          <a:lstStyle/>
+          <a:p>
+            <a:r>
+              <a:rPr lang="en-US" dirty="0"/>
+              <a:t>Example job submission script:</a:t>
+            </a:r>
+          </a:p>
+        </p:txBody>
+      </p:sp>
+      <p:sp>
+        <p:nvSpPr>
+          <p:cNvPr id="22" name="TextBox 21">
+            <a:extLst>
+              <a:ext uri="{FF2B5EF4-FFF2-40B4-BE49-F238E27FC236}">
+                <a16:creationId xmlns:a16="http://schemas.microsoft.com/office/drawing/2014/main" id="{C2EBE4C2-0FA6-720C-97E4-BB6D97794B0C}"/>
+              </a:ext>
+            </a:extLst>
+          </p:cNvPr>
+          <p:cNvSpPr txBox="1"/>
+          <p:nvPr/>
+        </p:nvSpPr>
+        <p:spPr>
+          <a:xfrm>
+            <a:off x="430009" y="6418830"/>
+            <a:ext cx="11568027" cy="338554"/>
+          </a:xfrm>
+          <a:prstGeom prst="rect">
+            <a:avLst/>
+          </a:prstGeom>
+          <a:noFill/>
+        </p:spPr>
+        <p:txBody>
+          <a:bodyPr wrap="square" rtlCol="0">
+            <a:spAutoFit/>
+          </a:bodyPr>
+          <a:lstStyle/>
+          <a:p>
+            <a:r>
+              <a:rPr lang="en-US" sz="1600" dirty="0"/>
+              <a:t>NOTE: My username is </a:t>
+            </a:r>
+            <a:r>
+              <a:rPr lang="en-US" sz="1600" dirty="0" err="1">
+                <a:solidFill>
+                  <a:schemeClr val="accent6">
+                    <a:lumMod val="75000"/>
+                  </a:schemeClr>
+                </a:solidFill>
+              </a:rPr>
+              <a:t>mbzlld</a:t>
+            </a:r>
+            <a:r>
+              <a:rPr lang="en-US" sz="1600" dirty="0"/>
+              <a:t> – where you see this in the scripts you will need to replace it with your own university username</a:t>
+            </a:r>
+          </a:p>
+        </p:txBody>
+      </p:sp>
+      <p:sp>
+        <p:nvSpPr>
+          <p:cNvPr id="3" name="Rectangle 2">
+            <a:extLst>
+              <a:ext uri="{FF2B5EF4-FFF2-40B4-BE49-F238E27FC236}">
+                <a16:creationId xmlns:a16="http://schemas.microsoft.com/office/drawing/2014/main" id="{A284D37C-D2D3-602F-B6BE-9CD91361225E}"/>
+              </a:ext>
+            </a:extLst>
+          </p:cNvPr>
+          <p:cNvSpPr/>
+          <p:nvPr/>
+        </p:nvSpPr>
+        <p:spPr>
+          <a:xfrm>
+            <a:off x="249382" y="2452259"/>
+            <a:ext cx="3467361" cy="332509"/>
+          </a:xfrm>
+          <a:prstGeom prst="rect">
+            <a:avLst/>
+          </a:prstGeom>
+          <a:solidFill>
+            <a:schemeClr val="accent1">
+              <a:alpha val="42761"/>
+            </a:schemeClr>
+          </a:solidFill>
+        </p:spPr>
+        <p:style>
+          <a:lnRef idx="2">
+            <a:schemeClr val="accent1">
+              <a:shade val="15000"/>
+            </a:schemeClr>
+          </a:lnRef>
+          <a:fillRef idx="1">
+            <a:schemeClr val="accent1"/>
+          </a:fillRef>
+          <a:effectRef idx="0">
+            <a:schemeClr val="accent1"/>
+          </a:effectRef>
+          <a:fontRef idx="minor">
+            <a:schemeClr val="lt1"/>
+          </a:fontRef>
+        </p:style>
+        <p:txBody>
+          <a:bodyPr rtlCol="0" anchor="ctr"/>
+          <a:lstStyle/>
+          <a:p>
+            <a:pPr algn="ctr"/>
+            <a:endParaRPr lang="en-US"/>
+          </a:p>
+        </p:txBody>
+      </p:sp>
+      <p:sp>
+        <p:nvSpPr>
+          <p:cNvPr id="4" name="TextBox 3">
+            <a:extLst>
+              <a:ext uri="{FF2B5EF4-FFF2-40B4-BE49-F238E27FC236}">
+                <a16:creationId xmlns:a16="http://schemas.microsoft.com/office/drawing/2014/main" id="{60ACBA33-0475-1859-940C-9B1ACA5219D4}"/>
+              </a:ext>
+            </a:extLst>
+          </p:cNvPr>
+          <p:cNvSpPr txBox="1"/>
+          <p:nvPr/>
+        </p:nvSpPr>
+        <p:spPr>
+          <a:xfrm>
+            <a:off x="7561376" y="1898073"/>
+            <a:ext cx="3605388" cy="2031325"/>
+          </a:xfrm>
+          <a:prstGeom prst="rect">
+            <a:avLst/>
+          </a:prstGeom>
+          <a:noFill/>
+        </p:spPr>
+        <p:txBody>
+          <a:bodyPr wrap="square" rtlCol="0">
+            <a:spAutoFit/>
+          </a:bodyPr>
+          <a:lstStyle/>
+          <a:p>
+            <a:r>
+              <a:rPr lang="en-US" dirty="0"/>
+              <a:t>--</a:t>
+            </a:r>
+            <a:r>
+              <a:rPr lang="en-US" dirty="0" err="1"/>
+              <a:t>ntasks</a:t>
+            </a:r>
+            <a:r>
+              <a:rPr lang="en-US" dirty="0"/>
+              <a:t>= </a:t>
+            </a:r>
+          </a:p>
+          <a:p>
+            <a:endParaRPr lang="en-US" dirty="0"/>
+          </a:p>
+          <a:p>
+            <a:r>
+              <a:rPr lang="en-US" dirty="0"/>
+              <a:t>Select how many separate tasks you want your job to be split across (for most jobs this will also be 1)</a:t>
+            </a:r>
+          </a:p>
+          <a:p>
+            <a:endParaRPr lang="en-US" dirty="0"/>
+          </a:p>
+        </p:txBody>
+      </p:sp>
+    </p:spTree>
+    <p:extLst>
+      <p:ext uri="{BB962C8B-B14F-4D97-AF65-F5344CB8AC3E}">
+        <p14:creationId xmlns:p14="http://schemas.microsoft.com/office/powerpoint/2010/main" val="458446712"/>
+      </p:ext>
+    </p:extLst>
+  </p:cSld>
+  <p:clrMapOvr>
+    <a:masterClrMapping/>
+  </p:clrMapOvr>
+</p:sld>
+</file>
+
+<file path=ppt/slides/slide11.xml><?xml version="1.0" encoding="utf-8"?>
+<p:sld xmlns:a="http://schemas.openxmlformats.org/drawingml/2006/main" xmlns:r="http://schemas.openxmlformats.org/officeDocument/2006/relationships" xmlns:p="http://schemas.openxmlformats.org/presentationml/2006/main">
+  <p:cSld>
+    <p:spTree>
+      <p:nvGrpSpPr>
+        <p:cNvPr id="1" name="">
+          <a:extLst>
+            <a:ext uri="{FF2B5EF4-FFF2-40B4-BE49-F238E27FC236}">
               <a16:creationId xmlns:a16="http://schemas.microsoft.com/office/drawing/2014/main" id="{09099056-F955-46E2-27A3-33A9140E569F}"/>
             </a:ext>
           </a:extLst>
@@ -8843,7 +9476,7 @@
 </p:sld>
 </file>
 
-<file path=ppt/slides/slide11.xml><?xml version="1.0" encoding="utf-8"?>
+<file path=ppt/slides/slide12.xml><?xml version="1.0" encoding="utf-8"?>
 <p:sld xmlns:a="http://schemas.openxmlformats.org/drawingml/2006/main" xmlns:r="http://schemas.openxmlformats.org/officeDocument/2006/relationships" xmlns:p="http://schemas.openxmlformats.org/presentationml/2006/main">
   <p:cSld>
     <p:spTree>
@@ -9356,7 +9989,7 @@
 </p:sld>
 </file>
 
-<file path=ppt/slides/slide12.xml><?xml version="1.0" encoding="utf-8"?>
+<file path=ppt/slides/slide13.xml><?xml version="1.0" encoding="utf-8"?>
 <p:sld xmlns:a="http://schemas.openxmlformats.org/drawingml/2006/main" xmlns:r="http://schemas.openxmlformats.org/officeDocument/2006/relationships" xmlns:p="http://schemas.openxmlformats.org/presentationml/2006/main">
   <p:cSld>
     <p:spTree>
@@ -9865,7 +10498,7 @@
 </p:sld>
 </file>
 
-<file path=ppt/slides/slide13.xml><?xml version="1.0" encoding="utf-8"?>
+<file path=ppt/slides/slide14.xml><?xml version="1.0" encoding="utf-8"?>
 <p:sld xmlns:a="http://schemas.openxmlformats.org/drawingml/2006/main" xmlns:r="http://schemas.openxmlformats.org/officeDocument/2006/relationships" xmlns:p="http://schemas.openxmlformats.org/presentationml/2006/main">
   <p:cSld>
     <p:spTree>
@@ -10349,7 +10982,7 @@
 </p:sld>
 </file>
 
-<file path=ppt/slides/slide14.xml><?xml version="1.0" encoding="utf-8"?>
+<file path=ppt/slides/slide15.xml><?xml version="1.0" encoding="utf-8"?>
 <p:sld xmlns:a="http://schemas.openxmlformats.org/drawingml/2006/main" xmlns:r="http://schemas.openxmlformats.org/officeDocument/2006/relationships" xmlns:p="http://schemas.openxmlformats.org/presentationml/2006/main">
   <p:cSld>
     <p:spTree>
@@ -10866,7 +11499,7 @@
 </p:sld>
 </file>
 
-<file path=ppt/slides/slide15.xml><?xml version="1.0" encoding="utf-8"?>
+<file path=ppt/slides/slide16.xml><?xml version="1.0" encoding="utf-8"?>
 <p:sld xmlns:a="http://schemas.openxmlformats.org/drawingml/2006/main" xmlns:r="http://schemas.openxmlformats.org/officeDocument/2006/relationships" xmlns:p="http://schemas.openxmlformats.org/presentationml/2006/main">
   <p:cSld>
     <p:spTree>
@@ -11383,7 +12016,7 @@
 </p:sld>
 </file>
 
-<file path=ppt/slides/slide16.xml><?xml version="1.0" encoding="utf-8"?>
+<file path=ppt/slides/slide17.xml><?xml version="1.0" encoding="utf-8"?>
 <p:sld xmlns:a="http://schemas.openxmlformats.org/drawingml/2006/main" xmlns:r="http://schemas.openxmlformats.org/officeDocument/2006/relationships" xmlns:p="http://schemas.openxmlformats.org/presentationml/2006/main">
   <p:cSld>
     <p:spTree>
@@ -11873,7 +12506,7 @@
 </p:sld>
 </file>
 
-<file path=ppt/slides/slide17.xml><?xml version="1.0" encoding="utf-8"?>
+<file path=ppt/slides/slide18.xml><?xml version="1.0" encoding="utf-8"?>
 <p:sld xmlns:a="http://schemas.openxmlformats.org/drawingml/2006/main" xmlns:r="http://schemas.openxmlformats.org/officeDocument/2006/relationships" xmlns:p="http://schemas.openxmlformats.org/presentationml/2006/main">
   <p:cSld>
     <p:spTree>
@@ -12351,7 +12984,7 @@
 </p:sld>
 </file>
 
-<file path=ppt/slides/slide18.xml><?xml version="1.0" encoding="utf-8"?>
+<file path=ppt/slides/slide19.xml><?xml version="1.0" encoding="utf-8"?>
 <p:sld xmlns:a="http://schemas.openxmlformats.org/drawingml/2006/main" xmlns:r="http://schemas.openxmlformats.org/officeDocument/2006/relationships" xmlns:p="http://schemas.openxmlformats.org/presentationml/2006/main">
   <p:cSld>
     <p:spTree>
@@ -12824,7 +13457,184 @@
 </p:sld>
 </file>
 
-<file path=ppt/slides/slide19.xml><?xml version="1.0" encoding="utf-8"?>
+<file path=ppt/slides/slide2.xml><?xml version="1.0" encoding="utf-8"?>
+<p:sld xmlns:a="http://schemas.openxmlformats.org/drawingml/2006/main" xmlns:r="http://schemas.openxmlformats.org/officeDocument/2006/relationships" xmlns:p="http://schemas.openxmlformats.org/presentationml/2006/main">
+  <p:cSld>
+    <p:spTree>
+      <p:nvGrpSpPr>
+        <p:cNvPr id="1" name="">
+          <a:extLst>
+            <a:ext uri="{FF2B5EF4-FFF2-40B4-BE49-F238E27FC236}">
+              <a16:creationId xmlns:a16="http://schemas.microsoft.com/office/drawing/2014/main" id="{9EA3A3AD-6155-A656-F920-FD1CDC6CBEF6}"/>
+            </a:ext>
+          </a:extLst>
+        </p:cNvPr>
+        <p:cNvGrpSpPr/>
+        <p:nvPr/>
+      </p:nvGrpSpPr>
+      <p:grpSpPr>
+        <a:xfrm>
+          <a:off x="0" y="0"/>
+          <a:ext cx="0" cy="0"/>
+          <a:chOff x="0" y="0"/>
+          <a:chExt cx="0" cy="0"/>
+        </a:xfrm>
+      </p:grpSpPr>
+      <p:sp>
+        <p:nvSpPr>
+          <p:cNvPr id="2" name="Title 1">
+            <a:extLst>
+              <a:ext uri="{FF2B5EF4-FFF2-40B4-BE49-F238E27FC236}">
+                <a16:creationId xmlns:a16="http://schemas.microsoft.com/office/drawing/2014/main" id="{C710A4FC-3C1C-5FCF-694F-F3286F802636}"/>
+              </a:ext>
+            </a:extLst>
+          </p:cNvPr>
+          <p:cNvSpPr>
+            <a:spLocks noGrp="1"/>
+          </p:cNvSpPr>
+          <p:nvPr>
+            <p:ph type="ctrTitle"/>
+          </p:nvPr>
+        </p:nvSpPr>
+        <p:spPr>
+          <a:xfrm>
+            <a:off x="451961" y="467791"/>
+            <a:ext cx="10896598" cy="557441"/>
+          </a:xfrm>
+        </p:spPr>
+        <p:txBody>
+          <a:bodyPr>
+            <a:noAutofit/>
+          </a:bodyPr>
+          <a:lstStyle/>
+          <a:p>
+            <a:r>
+              <a:rPr lang="en-US" sz="3600" dirty="0"/>
+              <a:t>First lets all get logged in and pull the </a:t>
+            </a:r>
+            <a:r>
+              <a:rPr lang="en-US" sz="3600" dirty="0" err="1"/>
+              <a:t>github</a:t>
+            </a:r>
+            <a:r>
+              <a:rPr lang="en-US" sz="3600" dirty="0"/>
+              <a:t> repo to Ada</a:t>
+            </a:r>
+          </a:p>
+        </p:txBody>
+      </p:sp>
+      <p:sp>
+        <p:nvSpPr>
+          <p:cNvPr id="5" name="TextBox 4">
+            <a:extLst>
+              <a:ext uri="{FF2B5EF4-FFF2-40B4-BE49-F238E27FC236}">
+                <a16:creationId xmlns:a16="http://schemas.microsoft.com/office/drawing/2014/main" id="{4B3F8C97-50B0-0ED6-7C76-A1CCC5154D72}"/>
+              </a:ext>
+            </a:extLst>
+          </p:cNvPr>
+          <p:cNvSpPr txBox="1"/>
+          <p:nvPr/>
+        </p:nvSpPr>
+        <p:spPr>
+          <a:xfrm>
+            <a:off x="228600" y="2459286"/>
+            <a:ext cx="11963400" cy="1701043"/>
+          </a:xfrm>
+          <a:prstGeom prst="rect">
+            <a:avLst/>
+          </a:prstGeom>
+          <a:noFill/>
+        </p:spPr>
+        <p:txBody>
+          <a:bodyPr wrap="square" rtlCol="0">
+            <a:spAutoFit/>
+          </a:bodyPr>
+          <a:lstStyle/>
+          <a:p>
+            <a:pPr>
+              <a:lnSpc>
+                <a:spcPct val="150000"/>
+              </a:lnSpc>
+            </a:pPr>
+            <a:r>
+              <a:rPr lang="en-US" sz="2400" dirty="0">
+                <a:latin typeface="Aptos Mono" panose="020B0009020202020204" pitchFamily="49" charset="0"/>
+              </a:rPr>
+              <a:t>ssh </a:t>
+            </a:r>
+            <a:r>
+              <a:rPr lang="en-US" sz="2400" dirty="0" err="1">
+                <a:latin typeface="Aptos Mono" panose="020B0009020202020204" pitchFamily="49" charset="0"/>
+              </a:rPr>
+              <a:t>ada</a:t>
+            </a:r>
+            <a:endParaRPr lang="en-US" sz="2400" dirty="0">
+              <a:latin typeface="Aptos Mono" panose="020B0009020202020204" pitchFamily="49" charset="0"/>
+            </a:endParaRPr>
+          </a:p>
+          <a:p>
+            <a:pPr>
+              <a:lnSpc>
+                <a:spcPct val="150000"/>
+              </a:lnSpc>
+            </a:pPr>
+            <a:endParaRPr lang="en-US" sz="2400" dirty="0">
+              <a:latin typeface="Aptos Mono" panose="020B0009020202020204" pitchFamily="49" charset="0"/>
+            </a:endParaRPr>
+          </a:p>
+          <a:p>
+            <a:pPr>
+              <a:lnSpc>
+                <a:spcPct val="150000"/>
+              </a:lnSpc>
+            </a:pPr>
+            <a:r>
+              <a:rPr lang="en-US" sz="2400" dirty="0">
+                <a:latin typeface="Aptos Mono" panose="020B0009020202020204" pitchFamily="49" charset="0"/>
+              </a:rPr>
+              <a:t>git clone https://</a:t>
+            </a:r>
+            <a:r>
+              <a:rPr lang="en-US" sz="2400" dirty="0" err="1">
+                <a:latin typeface="Aptos Mono" panose="020B0009020202020204" pitchFamily="49" charset="0"/>
+              </a:rPr>
+              <a:t>github.com</a:t>
+            </a:r>
+            <a:r>
+              <a:rPr lang="en-US" sz="2400" dirty="0">
+                <a:latin typeface="Aptos Mono" panose="020B0009020202020204" pitchFamily="49" charset="0"/>
+              </a:rPr>
+              <a:t>/</a:t>
+            </a:r>
+            <a:r>
+              <a:rPr lang="en-US" sz="2400" dirty="0" err="1">
+                <a:latin typeface="Aptos Mono" panose="020B0009020202020204" pitchFamily="49" charset="0"/>
+              </a:rPr>
+              <a:t>BioinformaticsMSc</a:t>
+            </a:r>
+            <a:r>
+              <a:rPr lang="en-US" sz="2400" dirty="0">
+                <a:latin typeface="Aptos Mono" panose="020B0009020202020204" pitchFamily="49" charset="0"/>
+              </a:rPr>
+              <a:t>/LIFE4138_2526.git</a:t>
+            </a:r>
+          </a:p>
+        </p:txBody>
+      </p:sp>
+    </p:spTree>
+    <p:extLst>
+      <p:ext uri="{BB962C8B-B14F-4D97-AF65-F5344CB8AC3E}">
+        <p14:creationId xmlns:p14="http://schemas.microsoft.com/office/powerpoint/2010/main" val="1517161138"/>
+      </p:ext>
+    </p:extLst>
+  </p:cSld>
+  <p:clrMapOvr>
+    <a:masterClrMapping/>
+  </p:clrMapOvr>
+</p:sld>
+</file>
+
+<file path=ppt/slides/slide20.xml><?xml version="1.0" encoding="utf-8"?>
 <p:sld xmlns:a="http://schemas.openxmlformats.org/drawingml/2006/main" xmlns:r="http://schemas.openxmlformats.org/officeDocument/2006/relationships" xmlns:p="http://schemas.openxmlformats.org/presentationml/2006/main">
   <p:cSld>
     <p:spTree>
@@ -13209,193 +14019,7 @@
 </p:sld>
 </file>
 
-<file path=ppt/slides/slide2.xml><?xml version="1.0" encoding="utf-8"?>
-<p:sld xmlns:a="http://schemas.openxmlformats.org/drawingml/2006/main" xmlns:r="http://schemas.openxmlformats.org/officeDocument/2006/relationships" xmlns:p="http://schemas.openxmlformats.org/presentationml/2006/main">
-  <p:cSld>
-    <p:spTree>
-      <p:nvGrpSpPr>
-        <p:cNvPr id="1" name="">
-          <a:extLst>
-            <a:ext uri="{FF2B5EF4-FFF2-40B4-BE49-F238E27FC236}">
-              <a16:creationId xmlns:a16="http://schemas.microsoft.com/office/drawing/2014/main" id="{A421E3B7-9420-C6EC-E715-63091610DBA6}"/>
-            </a:ext>
-          </a:extLst>
-        </p:cNvPr>
-        <p:cNvGrpSpPr/>
-        <p:nvPr/>
-      </p:nvGrpSpPr>
-      <p:grpSpPr>
-        <a:xfrm>
-          <a:off x="0" y="0"/>
-          <a:ext cx="0" cy="0"/>
-          <a:chOff x="0" y="0"/>
-          <a:chExt cx="0" cy="0"/>
-        </a:xfrm>
-      </p:grpSpPr>
-      <p:sp>
-        <p:nvSpPr>
-          <p:cNvPr id="2" name="Title 1">
-            <a:extLst>
-              <a:ext uri="{FF2B5EF4-FFF2-40B4-BE49-F238E27FC236}">
-                <a16:creationId xmlns:a16="http://schemas.microsoft.com/office/drawing/2014/main" id="{5B04C88C-FFC5-B020-42A3-661BBE00752F}"/>
-              </a:ext>
-            </a:extLst>
-          </p:cNvPr>
-          <p:cNvSpPr>
-            <a:spLocks noGrp="1"/>
-          </p:cNvSpPr>
-          <p:nvPr>
-            <p:ph type="ctrTitle"/>
-          </p:nvPr>
-        </p:nvSpPr>
-        <p:spPr>
-          <a:xfrm>
-            <a:off x="1523998" y="502081"/>
-            <a:ext cx="9144000" cy="557441"/>
-          </a:xfrm>
-        </p:spPr>
-        <p:txBody>
-          <a:bodyPr>
-            <a:noAutofit/>
-          </a:bodyPr>
-          <a:lstStyle/>
-          <a:p>
-            <a:r>
-              <a:rPr lang="en-US" sz="3600" dirty="0"/>
-              <a:t>Learning Objectives</a:t>
-            </a:r>
-          </a:p>
-        </p:txBody>
-      </p:sp>
-      <p:sp>
-        <p:nvSpPr>
-          <p:cNvPr id="5" name="TextBox 4">
-            <a:extLst>
-              <a:ext uri="{FF2B5EF4-FFF2-40B4-BE49-F238E27FC236}">
-                <a16:creationId xmlns:a16="http://schemas.microsoft.com/office/drawing/2014/main" id="{E529853A-E964-7B9A-D5BC-B3B7075AC096}"/>
-              </a:ext>
-            </a:extLst>
-          </p:cNvPr>
-          <p:cNvSpPr txBox="1"/>
-          <p:nvPr/>
-        </p:nvSpPr>
-        <p:spPr>
-          <a:xfrm>
-            <a:off x="1224342" y="1739196"/>
-            <a:ext cx="10147077" cy="3363037"/>
-          </a:xfrm>
-          <a:prstGeom prst="rect">
-            <a:avLst/>
-          </a:prstGeom>
-          <a:noFill/>
-        </p:spPr>
-        <p:txBody>
-          <a:bodyPr wrap="square" rtlCol="0">
-            <a:spAutoFit/>
-          </a:bodyPr>
-          <a:lstStyle/>
-          <a:p>
-            <a:pPr marL="342900" indent="-342900">
-              <a:lnSpc>
-                <a:spcPct val="150000"/>
-              </a:lnSpc>
-              <a:buFont typeface="Arial" panose="020B0604020202020204" pitchFamily="34" charset="0"/>
-              <a:buChar char="•"/>
-            </a:pPr>
-            <a:r>
-              <a:rPr lang="en-US" sz="2400" dirty="0"/>
-              <a:t>Know how to write a job submission script</a:t>
-            </a:r>
-          </a:p>
-          <a:p>
-            <a:pPr marL="342900" indent="-342900">
-              <a:lnSpc>
-                <a:spcPct val="150000"/>
-              </a:lnSpc>
-              <a:buFont typeface="Arial" panose="020B0604020202020204" pitchFamily="34" charset="0"/>
-              <a:buChar char="•"/>
-            </a:pPr>
-            <a:r>
-              <a:rPr lang="en-US" sz="2400" dirty="0"/>
-              <a:t>Know how to submit and manage a job using basic </a:t>
-            </a:r>
-            <a:r>
-              <a:rPr lang="en-US" sz="2400" dirty="0" err="1"/>
-              <a:t>slurm</a:t>
-            </a:r>
-            <a:r>
-              <a:rPr lang="en-US" sz="2400" dirty="0"/>
-              <a:t> commands</a:t>
-            </a:r>
-          </a:p>
-          <a:p>
-            <a:pPr marL="342900" indent="-342900">
-              <a:lnSpc>
-                <a:spcPct val="150000"/>
-              </a:lnSpc>
-              <a:buFont typeface="Arial" panose="020B0604020202020204" pitchFamily="34" charset="0"/>
-              <a:buChar char="•"/>
-            </a:pPr>
-            <a:r>
-              <a:rPr lang="en-US" sz="2400" dirty="0"/>
-              <a:t>Know how to request an interactive job</a:t>
-            </a:r>
-          </a:p>
-          <a:p>
-            <a:pPr marL="342900" indent="-342900">
-              <a:lnSpc>
-                <a:spcPct val="150000"/>
-              </a:lnSpc>
-              <a:buFont typeface="Arial" panose="020B0604020202020204" pitchFamily="34" charset="0"/>
-              <a:buChar char="•"/>
-            </a:pPr>
-            <a:r>
-              <a:rPr lang="en-US" sz="2400" dirty="0"/>
-              <a:t>Know how to access software on the HPC</a:t>
-            </a:r>
-          </a:p>
-          <a:p>
-            <a:pPr marL="342900" indent="-342900">
-              <a:lnSpc>
-                <a:spcPct val="150000"/>
-              </a:lnSpc>
-              <a:buFont typeface="Arial" panose="020B0604020202020204" pitchFamily="34" charset="0"/>
-              <a:buChar char="•"/>
-            </a:pPr>
-            <a:r>
-              <a:rPr lang="en-US" sz="2400" dirty="0"/>
-              <a:t>Know how to copy files between the HPC and your local machine</a:t>
-            </a:r>
-          </a:p>
-          <a:p>
-            <a:pPr marL="342900" indent="-342900">
-              <a:lnSpc>
-                <a:spcPct val="150000"/>
-              </a:lnSpc>
-              <a:buFont typeface="Arial" panose="020B0604020202020204" pitchFamily="34" charset="0"/>
-              <a:buChar char="•"/>
-            </a:pPr>
-            <a:r>
-              <a:rPr lang="en-US" sz="2400" dirty="0"/>
-              <a:t>Know where to go for further support</a:t>
-            </a:r>
-          </a:p>
-        </p:txBody>
-      </p:sp>
-    </p:spTree>
-    <p:extLst>
-      <p:ext uri="{BB962C8B-B14F-4D97-AF65-F5344CB8AC3E}">
-        <p14:creationId xmlns:p14="http://schemas.microsoft.com/office/powerpoint/2010/main" val="1839439955"/>
-      </p:ext>
-    </p:extLst>
-  </p:cSld>
-  <p:clrMapOvr>
-    <a:masterClrMapping/>
-  </p:clrMapOvr>
-</p:sld>
-</file>
-
-<file path=ppt/slides/slide20.xml><?xml version="1.0" encoding="utf-8"?>
+<file path=ppt/slides/slide21.xml><?xml version="1.0" encoding="utf-8"?>
 <p:sld xmlns:a="http://schemas.openxmlformats.org/drawingml/2006/main" xmlns:r="http://schemas.openxmlformats.org/officeDocument/2006/relationships" xmlns:p="http://schemas.openxmlformats.org/presentationml/2006/main">
   <p:cSld>
     <p:spTree>
@@ -13722,7 +14346,7 @@
 </p:sld>
 </file>
 
-<file path=ppt/slides/slide21.xml><?xml version="1.0" encoding="utf-8"?>
+<file path=ppt/slides/slide22.xml><?xml version="1.0" encoding="utf-8"?>
 <p:sld xmlns:a="http://schemas.openxmlformats.org/drawingml/2006/main" xmlns:r="http://schemas.openxmlformats.org/officeDocument/2006/relationships" xmlns:p="http://schemas.openxmlformats.org/presentationml/2006/main">
   <p:cSld>
     <p:spTree>
@@ -14952,7 +15576,7 @@
 </p:sld>
 </file>
 
-<file path=ppt/slides/slide22.xml><?xml version="1.0" encoding="utf-8"?>
+<file path=ppt/slides/slide23.xml><?xml version="1.0" encoding="utf-8"?>
 <p:sld xmlns:a="http://schemas.openxmlformats.org/drawingml/2006/main" xmlns:r="http://schemas.openxmlformats.org/officeDocument/2006/relationships" xmlns:p="http://schemas.openxmlformats.org/presentationml/2006/main">
   <p:cSld>
     <p:spTree>
@@ -15298,7 +15922,7 @@
 </p:sld>
 </file>
 
-<file path=ppt/slides/slide23.xml><?xml version="1.0" encoding="utf-8"?>
+<file path=ppt/slides/slide24.xml><?xml version="1.0" encoding="utf-8"?>
 <p:sld xmlns:a="http://schemas.openxmlformats.org/drawingml/2006/main" xmlns:r="http://schemas.openxmlformats.org/officeDocument/2006/relationships" xmlns:p="http://schemas.openxmlformats.org/presentationml/2006/main">
   <p:cSld>
     <p:spTree>
@@ -16020,7 +16644,7 @@
 </p:sld>
 </file>
 
-<file path=ppt/slides/slide24.xml><?xml version="1.0" encoding="utf-8"?>
+<file path=ppt/slides/slide25.xml><?xml version="1.0" encoding="utf-8"?>
 <p:sld xmlns:a="http://schemas.openxmlformats.org/drawingml/2006/main" xmlns:r="http://schemas.openxmlformats.org/officeDocument/2006/relationships" xmlns:p="http://schemas.openxmlformats.org/presentationml/2006/main">
   <p:cSld>
     <p:spTree>
@@ -16366,7 +16990,7 @@
 </p:sld>
 </file>
 
-<file path=ppt/slides/slide25.xml><?xml version="1.0" encoding="utf-8"?>
+<file path=ppt/slides/slide26.xml><?xml version="1.0" encoding="utf-8"?>
 <p:sld xmlns:a="http://schemas.openxmlformats.org/drawingml/2006/main" xmlns:r="http://schemas.openxmlformats.org/officeDocument/2006/relationships" xmlns:p="http://schemas.openxmlformats.org/presentationml/2006/main">
   <p:cSld>
     <p:spTree>
@@ -16516,7 +17140,7 @@
 </p:sld>
 </file>
 
-<file path=ppt/slides/slide26.xml><?xml version="1.0" encoding="utf-8"?>
+<file path=ppt/slides/slide27.xml><?xml version="1.0" encoding="utf-8"?>
 <p:sld xmlns:a="http://schemas.openxmlformats.org/drawingml/2006/main" xmlns:r="http://schemas.openxmlformats.org/officeDocument/2006/relationships" xmlns:p="http://schemas.openxmlformats.org/presentationml/2006/main">
   <p:cSld>
     <p:spTree>
@@ -17000,7 +17624,7 @@
 </p:sld>
 </file>
 
-<file path=ppt/slides/slide27.xml><?xml version="1.0" encoding="utf-8"?>
+<file path=ppt/slides/slide28.xml><?xml version="1.0" encoding="utf-8"?>
 <p:sld xmlns:a="http://schemas.openxmlformats.org/drawingml/2006/main" xmlns:r="http://schemas.openxmlformats.org/officeDocument/2006/relationships" xmlns:p="http://schemas.openxmlformats.org/presentationml/2006/main">
   <p:cSld>
     <p:spTree>
@@ -18885,7 +19509,7 @@
 </p:sld>
 </file>
 
-<file path=ppt/slides/slide28.xml><?xml version="1.0" encoding="utf-8"?>
+<file path=ppt/slides/slide29.xml><?xml version="1.0" encoding="utf-8"?>
 <p:sld xmlns:a="http://schemas.openxmlformats.org/drawingml/2006/main" xmlns:r="http://schemas.openxmlformats.org/officeDocument/2006/relationships" xmlns:p="http://schemas.openxmlformats.org/presentationml/2006/main">
   <p:cSld>
     <p:spTree>
@@ -19141,7 +19765,193 @@
 </p:sld>
 </file>
 
-<file path=ppt/slides/slide29.xml><?xml version="1.0" encoding="utf-8"?>
+<file path=ppt/slides/slide3.xml><?xml version="1.0" encoding="utf-8"?>
+<p:sld xmlns:a="http://schemas.openxmlformats.org/drawingml/2006/main" xmlns:r="http://schemas.openxmlformats.org/officeDocument/2006/relationships" xmlns:p="http://schemas.openxmlformats.org/presentationml/2006/main">
+  <p:cSld>
+    <p:spTree>
+      <p:nvGrpSpPr>
+        <p:cNvPr id="1" name="">
+          <a:extLst>
+            <a:ext uri="{FF2B5EF4-FFF2-40B4-BE49-F238E27FC236}">
+              <a16:creationId xmlns:a16="http://schemas.microsoft.com/office/drawing/2014/main" id="{A421E3B7-9420-C6EC-E715-63091610DBA6}"/>
+            </a:ext>
+          </a:extLst>
+        </p:cNvPr>
+        <p:cNvGrpSpPr/>
+        <p:nvPr/>
+      </p:nvGrpSpPr>
+      <p:grpSpPr>
+        <a:xfrm>
+          <a:off x="0" y="0"/>
+          <a:ext cx="0" cy="0"/>
+          <a:chOff x="0" y="0"/>
+          <a:chExt cx="0" cy="0"/>
+        </a:xfrm>
+      </p:grpSpPr>
+      <p:sp>
+        <p:nvSpPr>
+          <p:cNvPr id="2" name="Title 1">
+            <a:extLst>
+              <a:ext uri="{FF2B5EF4-FFF2-40B4-BE49-F238E27FC236}">
+                <a16:creationId xmlns:a16="http://schemas.microsoft.com/office/drawing/2014/main" id="{5B04C88C-FFC5-B020-42A3-661BBE00752F}"/>
+              </a:ext>
+            </a:extLst>
+          </p:cNvPr>
+          <p:cNvSpPr>
+            <a:spLocks noGrp="1"/>
+          </p:cNvSpPr>
+          <p:nvPr>
+            <p:ph type="ctrTitle"/>
+          </p:nvPr>
+        </p:nvSpPr>
+        <p:spPr>
+          <a:xfrm>
+            <a:off x="1523998" y="502081"/>
+            <a:ext cx="9144000" cy="557441"/>
+          </a:xfrm>
+        </p:spPr>
+        <p:txBody>
+          <a:bodyPr>
+            <a:noAutofit/>
+          </a:bodyPr>
+          <a:lstStyle/>
+          <a:p>
+            <a:r>
+              <a:rPr lang="en-US" sz="3600" dirty="0"/>
+              <a:t>Learning Objectives</a:t>
+            </a:r>
+          </a:p>
+        </p:txBody>
+      </p:sp>
+      <p:sp>
+        <p:nvSpPr>
+          <p:cNvPr id="5" name="TextBox 4">
+            <a:extLst>
+              <a:ext uri="{FF2B5EF4-FFF2-40B4-BE49-F238E27FC236}">
+                <a16:creationId xmlns:a16="http://schemas.microsoft.com/office/drawing/2014/main" id="{E529853A-E964-7B9A-D5BC-B3B7075AC096}"/>
+              </a:ext>
+            </a:extLst>
+          </p:cNvPr>
+          <p:cNvSpPr txBox="1"/>
+          <p:nvPr/>
+        </p:nvSpPr>
+        <p:spPr>
+          <a:xfrm>
+            <a:off x="1224342" y="1739196"/>
+            <a:ext cx="10147077" cy="3363037"/>
+          </a:xfrm>
+          <a:prstGeom prst="rect">
+            <a:avLst/>
+          </a:prstGeom>
+          <a:noFill/>
+        </p:spPr>
+        <p:txBody>
+          <a:bodyPr wrap="square" rtlCol="0">
+            <a:spAutoFit/>
+          </a:bodyPr>
+          <a:lstStyle/>
+          <a:p>
+            <a:pPr marL="342900" indent="-342900">
+              <a:lnSpc>
+                <a:spcPct val="150000"/>
+              </a:lnSpc>
+              <a:buFont typeface="Arial" panose="020B0604020202020204" pitchFamily="34" charset="0"/>
+              <a:buChar char="•"/>
+            </a:pPr>
+            <a:r>
+              <a:rPr lang="en-US" sz="2400" dirty="0"/>
+              <a:t>Know how to write a job submission script</a:t>
+            </a:r>
+          </a:p>
+          <a:p>
+            <a:pPr marL="342900" indent="-342900">
+              <a:lnSpc>
+                <a:spcPct val="150000"/>
+              </a:lnSpc>
+              <a:buFont typeface="Arial" panose="020B0604020202020204" pitchFamily="34" charset="0"/>
+              <a:buChar char="•"/>
+            </a:pPr>
+            <a:r>
+              <a:rPr lang="en-US" sz="2400" dirty="0"/>
+              <a:t>Know how to submit and manage a job using basic </a:t>
+            </a:r>
+            <a:r>
+              <a:rPr lang="en-US" sz="2400" dirty="0" err="1"/>
+              <a:t>slurm</a:t>
+            </a:r>
+            <a:r>
+              <a:rPr lang="en-US" sz="2400" dirty="0"/>
+              <a:t> commands</a:t>
+            </a:r>
+          </a:p>
+          <a:p>
+            <a:pPr marL="342900" indent="-342900">
+              <a:lnSpc>
+                <a:spcPct val="150000"/>
+              </a:lnSpc>
+              <a:buFont typeface="Arial" panose="020B0604020202020204" pitchFamily="34" charset="0"/>
+              <a:buChar char="•"/>
+            </a:pPr>
+            <a:r>
+              <a:rPr lang="en-US" sz="2400" dirty="0"/>
+              <a:t>Know how to request an interactive job</a:t>
+            </a:r>
+          </a:p>
+          <a:p>
+            <a:pPr marL="342900" indent="-342900">
+              <a:lnSpc>
+                <a:spcPct val="150000"/>
+              </a:lnSpc>
+              <a:buFont typeface="Arial" panose="020B0604020202020204" pitchFamily="34" charset="0"/>
+              <a:buChar char="•"/>
+            </a:pPr>
+            <a:r>
+              <a:rPr lang="en-US" sz="2400" dirty="0"/>
+              <a:t>Know how to access software on the HPC</a:t>
+            </a:r>
+          </a:p>
+          <a:p>
+            <a:pPr marL="342900" indent="-342900">
+              <a:lnSpc>
+                <a:spcPct val="150000"/>
+              </a:lnSpc>
+              <a:buFont typeface="Arial" panose="020B0604020202020204" pitchFamily="34" charset="0"/>
+              <a:buChar char="•"/>
+            </a:pPr>
+            <a:r>
+              <a:rPr lang="en-US" sz="2400" dirty="0"/>
+              <a:t>Know how to copy files between the HPC and your local machine</a:t>
+            </a:r>
+          </a:p>
+          <a:p>
+            <a:pPr marL="342900" indent="-342900">
+              <a:lnSpc>
+                <a:spcPct val="150000"/>
+              </a:lnSpc>
+              <a:buFont typeface="Arial" panose="020B0604020202020204" pitchFamily="34" charset="0"/>
+              <a:buChar char="•"/>
+            </a:pPr>
+            <a:r>
+              <a:rPr lang="en-US" sz="2400" dirty="0"/>
+              <a:t>Know where to go for further support</a:t>
+            </a:r>
+          </a:p>
+        </p:txBody>
+      </p:sp>
+    </p:spTree>
+    <p:extLst>
+      <p:ext uri="{BB962C8B-B14F-4D97-AF65-F5344CB8AC3E}">
+        <p14:creationId xmlns:p14="http://schemas.microsoft.com/office/powerpoint/2010/main" val="1839439955"/>
+      </p:ext>
+    </p:extLst>
+  </p:cSld>
+  <p:clrMapOvr>
+    <a:masterClrMapping/>
+  </p:clrMapOvr>
+</p:sld>
+</file>
+
+<file path=ppt/slides/slide30.xml><?xml version="1.0" encoding="utf-8"?>
 <p:sld xmlns:a="http://schemas.openxmlformats.org/drawingml/2006/main" xmlns:r="http://schemas.openxmlformats.org/officeDocument/2006/relationships" xmlns:p="http://schemas.openxmlformats.org/presentationml/2006/main">
   <p:cSld>
     <p:spTree>
@@ -19705,174 +20515,7 @@
 </p:sld>
 </file>
 
-<file path=ppt/slides/slide3.xml><?xml version="1.0" encoding="utf-8"?>
-<p:sld xmlns:a="http://schemas.openxmlformats.org/drawingml/2006/main" xmlns:r="http://schemas.openxmlformats.org/officeDocument/2006/relationships" xmlns:p="http://schemas.openxmlformats.org/presentationml/2006/main">
-  <p:cSld>
-    <p:spTree>
-      <p:nvGrpSpPr>
-        <p:cNvPr id="1" name=""/>
-        <p:cNvGrpSpPr/>
-        <p:nvPr/>
-      </p:nvGrpSpPr>
-      <p:grpSpPr>
-        <a:xfrm>
-          <a:off x="0" y="0"/>
-          <a:ext cx="0" cy="0"/>
-          <a:chOff x="0" y="0"/>
-          <a:chExt cx="0" cy="0"/>
-        </a:xfrm>
-      </p:grpSpPr>
-      <p:sp>
-        <p:nvSpPr>
-          <p:cNvPr id="3" name="Content Placeholder 2">
-            <a:extLst>
-              <a:ext uri="{FF2B5EF4-FFF2-40B4-BE49-F238E27FC236}">
-                <a16:creationId xmlns:a16="http://schemas.microsoft.com/office/drawing/2014/main" id="{B9C7C29B-4FF8-AE43-AB2B-C9A96454FED5}"/>
-              </a:ext>
-            </a:extLst>
-          </p:cNvPr>
-          <p:cNvSpPr>
-            <a:spLocks noGrp="1"/>
-          </p:cNvSpPr>
-          <p:nvPr>
-            <p:ph idx="1"/>
-          </p:nvPr>
-        </p:nvSpPr>
-        <p:spPr>
-          <a:xfrm>
-            <a:off x="838200" y="6091237"/>
-            <a:ext cx="10515600" cy="553403"/>
-          </a:xfrm>
-        </p:spPr>
-        <p:txBody>
-          <a:bodyPr/>
-          <a:lstStyle/>
-          <a:p>
-            <a:pPr marL="0" indent="0" algn="ctr">
-              <a:buNone/>
-            </a:pPr>
-            <a:r>
-              <a:rPr lang="en-US" dirty="0"/>
-              <a:t>https://</a:t>
-            </a:r>
-            <a:r>
-              <a:rPr lang="en-US" dirty="0" err="1"/>
-              <a:t>slurm.schedmd.com</a:t>
-            </a:r>
-            <a:r>
-              <a:rPr lang="en-US" dirty="0"/>
-              <a:t>/</a:t>
-            </a:r>
-            <a:r>
-              <a:rPr lang="en-US" dirty="0" err="1"/>
-              <a:t>documentation.html</a:t>
-            </a:r>
-            <a:endParaRPr lang="en-US" dirty="0"/>
-          </a:p>
-          <a:p>
-            <a:pPr marL="0" indent="0">
-              <a:buNone/>
-            </a:pPr>
-            <a:endParaRPr lang="en-US" dirty="0"/>
-          </a:p>
-        </p:txBody>
-      </p:sp>
-      <p:pic>
-        <p:nvPicPr>
-          <p:cNvPr id="20482" name="Picture 2" descr="Slurm Workload Manager - Wikipedia">
-            <a:extLst>
-              <a:ext uri="{FF2B5EF4-FFF2-40B4-BE49-F238E27FC236}">
-                <a16:creationId xmlns:a16="http://schemas.microsoft.com/office/drawing/2014/main" id="{C856A0BC-47EF-EF4B-B140-91A463D8C9DF}"/>
-              </a:ext>
-            </a:extLst>
-          </p:cNvPr>
-          <p:cNvPicPr>
-            <a:picLocks noChangeAspect="1" noChangeArrowheads="1"/>
-          </p:cNvPicPr>
-          <p:nvPr/>
-        </p:nvPicPr>
-        <p:blipFill>
-          <a:blip r:embed="rId3">
-            <a:extLst>
-              <a:ext uri="{28A0092B-C50C-407E-A947-70E740481C1C}">
-                <a14:useLocalDpi xmlns:a14="http://schemas.microsoft.com/office/drawing/2010/main" val="0"/>
-              </a:ext>
-            </a:extLst>
-          </a:blip>
-          <a:srcRect/>
-          <a:stretch>
-            <a:fillRect/>
-          </a:stretch>
-        </p:blipFill>
-        <p:spPr bwMode="auto">
-          <a:xfrm>
-            <a:off x="3546547" y="213360"/>
-            <a:ext cx="4819247" cy="4409902"/>
-          </a:xfrm>
-          <a:prstGeom prst="rect">
-            <a:avLst/>
-          </a:prstGeom>
-          <a:noFill/>
-          <a:extLst>
-            <a:ext uri="{909E8E84-426E-40DD-AFC4-6F175D3DCCD1}">
-              <a14:hiddenFill xmlns:a14="http://schemas.microsoft.com/office/drawing/2010/main">
-                <a:solidFill>
-                  <a:srgbClr val="FFFFFF"/>
-                </a:solidFill>
-              </a14:hiddenFill>
-            </a:ext>
-          </a:extLst>
-        </p:spPr>
-      </p:pic>
-      <p:sp>
-        <p:nvSpPr>
-          <p:cNvPr id="4" name="TextBox 3">
-            <a:extLst>
-              <a:ext uri="{FF2B5EF4-FFF2-40B4-BE49-F238E27FC236}">
-                <a16:creationId xmlns:a16="http://schemas.microsoft.com/office/drawing/2014/main" id="{E0A9EF8D-7BB0-081A-DCAF-DEA985BF3554}"/>
-              </a:ext>
-            </a:extLst>
-          </p:cNvPr>
-          <p:cNvSpPr txBox="1"/>
-          <p:nvPr/>
-        </p:nvSpPr>
-        <p:spPr>
-          <a:xfrm>
-            <a:off x="3207327" y="4987917"/>
-            <a:ext cx="6255327" cy="369332"/>
-          </a:xfrm>
-          <a:prstGeom prst="rect">
-            <a:avLst/>
-          </a:prstGeom>
-          <a:noFill/>
-        </p:spPr>
-        <p:txBody>
-          <a:bodyPr wrap="square">
-            <a:spAutoFit/>
-          </a:bodyPr>
-          <a:lstStyle/>
-          <a:p>
-            <a:r>
-              <a:rPr lang="en-US" dirty="0"/>
-              <a:t>SLURM – Simple Linux Utility for Resource Management</a:t>
-            </a:r>
-          </a:p>
-        </p:txBody>
-      </p:sp>
-    </p:spTree>
-    <p:extLst>
-      <p:ext uri="{BB962C8B-B14F-4D97-AF65-F5344CB8AC3E}">
-        <p14:creationId xmlns:p14="http://schemas.microsoft.com/office/powerpoint/2010/main" val="2972566723"/>
-      </p:ext>
-    </p:extLst>
-  </p:cSld>
-  <p:clrMapOvr>
-    <a:masterClrMapping/>
-  </p:clrMapOvr>
-</p:sld>
-</file>
-
-<file path=ppt/slides/slide30.xml><?xml version="1.0" encoding="utf-8"?>
+<file path=ppt/slides/slide31.xml><?xml version="1.0" encoding="utf-8"?>
 <p:sld xmlns:a="http://schemas.openxmlformats.org/drawingml/2006/main" xmlns:r="http://schemas.openxmlformats.org/officeDocument/2006/relationships" xmlns:p="http://schemas.openxmlformats.org/presentationml/2006/main">
   <p:cSld>
     <p:spTree>
@@ -20324,7 +20967,7 @@
 </p:sld>
 </file>
 
-<file path=ppt/slides/slide31.xml><?xml version="1.0" encoding="utf-8"?>
+<file path=ppt/slides/slide32.xml><?xml version="1.0" encoding="utf-8"?>
 <p:sld xmlns:a="http://schemas.openxmlformats.org/drawingml/2006/main" xmlns:r="http://schemas.openxmlformats.org/officeDocument/2006/relationships" xmlns:p="http://schemas.openxmlformats.org/presentationml/2006/main">
   <p:cSld>
     <p:spTree>
@@ -20820,7 +21463,7 @@
 </p:sld>
 </file>
 
-<file path=ppt/slides/slide32.xml><?xml version="1.0" encoding="utf-8"?>
+<file path=ppt/slides/slide33.xml><?xml version="1.0" encoding="utf-8"?>
 <p:sld xmlns:a="http://schemas.openxmlformats.org/drawingml/2006/main" xmlns:r="http://schemas.openxmlformats.org/officeDocument/2006/relationships" xmlns:p="http://schemas.openxmlformats.org/presentationml/2006/main">
   <p:cSld>
     <p:spTree>
@@ -21070,7 +21713,7 @@
 </p:sld>
 </file>
 
-<file path=ppt/slides/slide33.xml><?xml version="1.0" encoding="utf-8"?>
+<file path=ppt/slides/slide34.xml><?xml version="1.0" encoding="utf-8"?>
 <p:sld xmlns:a="http://schemas.openxmlformats.org/drawingml/2006/main" xmlns:r="http://schemas.openxmlformats.org/officeDocument/2006/relationships" xmlns:p="http://schemas.openxmlformats.org/presentationml/2006/main">
   <p:cSld>
     <p:spTree>
@@ -21277,7 +21920,7 @@
 </p:sld>
 </file>
 
-<file path=ppt/slides/slide34.xml><?xml version="1.0" encoding="utf-8"?>
+<file path=ppt/slides/slide35.xml><?xml version="1.0" encoding="utf-8"?>
 <p:sld xmlns:a="http://schemas.openxmlformats.org/drawingml/2006/main" xmlns:r="http://schemas.openxmlformats.org/officeDocument/2006/relationships" xmlns:p="http://schemas.openxmlformats.org/presentationml/2006/main">
   <p:cSld>
     <p:spTree>
@@ -22166,7 +22809,7 @@
 </p:sld>
 </file>
 
-<file path=ppt/slides/slide35.xml><?xml version="1.0" encoding="utf-8"?>
+<file path=ppt/slides/slide36.xml><?xml version="1.0" encoding="utf-8"?>
 <p:sld xmlns:a="http://schemas.openxmlformats.org/drawingml/2006/main" xmlns:r="http://schemas.openxmlformats.org/officeDocument/2006/relationships" xmlns:p="http://schemas.openxmlformats.org/presentationml/2006/main">
   <p:cSld>
     <p:spTree>
@@ -22823,7 +23466,7 @@
 </p:sld>
 </file>
 
-<file path=ppt/slides/slide36.xml><?xml version="1.0" encoding="utf-8"?>
+<file path=ppt/slides/slide37.xml><?xml version="1.0" encoding="utf-8"?>
 <p:sld xmlns:a="http://schemas.openxmlformats.org/drawingml/2006/main" xmlns:r="http://schemas.openxmlformats.org/officeDocument/2006/relationships" xmlns:p="http://schemas.openxmlformats.org/presentationml/2006/main">
   <p:cSld>
     <p:spTree>
@@ -23896,7 +24539,7 @@
 </p:sld>
 </file>
 
-<file path=ppt/slides/slide37.xml><?xml version="1.0" encoding="utf-8"?>
+<file path=ppt/slides/slide38.xml><?xml version="1.0" encoding="utf-8"?>
 <p:sld xmlns:a="http://schemas.openxmlformats.org/drawingml/2006/main" xmlns:r="http://schemas.openxmlformats.org/officeDocument/2006/relationships" xmlns:p="http://schemas.openxmlformats.org/presentationml/2006/main">
   <p:cSld>
     <p:spTree>
@@ -24946,7 +25589,7 @@
 </p:sld>
 </file>
 
-<file path=ppt/slides/slide38.xml><?xml version="1.0" encoding="utf-8"?>
+<file path=ppt/slides/slide39.xml><?xml version="1.0" encoding="utf-8"?>
 <p:sld xmlns:a="http://schemas.openxmlformats.org/drawingml/2006/main" xmlns:r="http://schemas.openxmlformats.org/officeDocument/2006/relationships" xmlns:p="http://schemas.openxmlformats.org/presentationml/2006/main">
   <p:cSld>
     <p:spTree>
@@ -25437,7 +26080,174 @@
 </p:sld>
 </file>
 
-<file path=ppt/slides/slide39.xml><?xml version="1.0" encoding="utf-8"?>
+<file path=ppt/slides/slide4.xml><?xml version="1.0" encoding="utf-8"?>
+<p:sld xmlns:a="http://schemas.openxmlformats.org/drawingml/2006/main" xmlns:r="http://schemas.openxmlformats.org/officeDocument/2006/relationships" xmlns:p="http://schemas.openxmlformats.org/presentationml/2006/main">
+  <p:cSld>
+    <p:spTree>
+      <p:nvGrpSpPr>
+        <p:cNvPr id="1" name=""/>
+        <p:cNvGrpSpPr/>
+        <p:nvPr/>
+      </p:nvGrpSpPr>
+      <p:grpSpPr>
+        <a:xfrm>
+          <a:off x="0" y="0"/>
+          <a:ext cx="0" cy="0"/>
+          <a:chOff x="0" y="0"/>
+          <a:chExt cx="0" cy="0"/>
+        </a:xfrm>
+      </p:grpSpPr>
+      <p:sp>
+        <p:nvSpPr>
+          <p:cNvPr id="3" name="Content Placeholder 2">
+            <a:extLst>
+              <a:ext uri="{FF2B5EF4-FFF2-40B4-BE49-F238E27FC236}">
+                <a16:creationId xmlns:a16="http://schemas.microsoft.com/office/drawing/2014/main" id="{B9C7C29B-4FF8-AE43-AB2B-C9A96454FED5}"/>
+              </a:ext>
+            </a:extLst>
+          </p:cNvPr>
+          <p:cNvSpPr>
+            <a:spLocks noGrp="1"/>
+          </p:cNvSpPr>
+          <p:nvPr>
+            <p:ph idx="1"/>
+          </p:nvPr>
+        </p:nvSpPr>
+        <p:spPr>
+          <a:xfrm>
+            <a:off x="838200" y="6091237"/>
+            <a:ext cx="10515600" cy="553403"/>
+          </a:xfrm>
+        </p:spPr>
+        <p:txBody>
+          <a:bodyPr/>
+          <a:lstStyle/>
+          <a:p>
+            <a:pPr marL="0" indent="0" algn="ctr">
+              <a:buNone/>
+            </a:pPr>
+            <a:r>
+              <a:rPr lang="en-US" dirty="0"/>
+              <a:t>https://</a:t>
+            </a:r>
+            <a:r>
+              <a:rPr lang="en-US" dirty="0" err="1"/>
+              <a:t>slurm.schedmd.com</a:t>
+            </a:r>
+            <a:r>
+              <a:rPr lang="en-US" dirty="0"/>
+              <a:t>/</a:t>
+            </a:r>
+            <a:r>
+              <a:rPr lang="en-US" dirty="0" err="1"/>
+              <a:t>documentation.html</a:t>
+            </a:r>
+            <a:endParaRPr lang="en-US" dirty="0"/>
+          </a:p>
+          <a:p>
+            <a:pPr marL="0" indent="0">
+              <a:buNone/>
+            </a:pPr>
+            <a:endParaRPr lang="en-US" dirty="0"/>
+          </a:p>
+        </p:txBody>
+      </p:sp>
+      <p:pic>
+        <p:nvPicPr>
+          <p:cNvPr id="20482" name="Picture 2" descr="Slurm Workload Manager - Wikipedia">
+            <a:extLst>
+              <a:ext uri="{FF2B5EF4-FFF2-40B4-BE49-F238E27FC236}">
+                <a16:creationId xmlns:a16="http://schemas.microsoft.com/office/drawing/2014/main" id="{C856A0BC-47EF-EF4B-B140-91A463D8C9DF}"/>
+              </a:ext>
+            </a:extLst>
+          </p:cNvPr>
+          <p:cNvPicPr>
+            <a:picLocks noChangeAspect="1" noChangeArrowheads="1"/>
+          </p:cNvPicPr>
+          <p:nvPr/>
+        </p:nvPicPr>
+        <p:blipFill>
+          <a:blip r:embed="rId3">
+            <a:extLst>
+              <a:ext uri="{28A0092B-C50C-407E-A947-70E740481C1C}">
+                <a14:useLocalDpi xmlns:a14="http://schemas.microsoft.com/office/drawing/2010/main" val="0"/>
+              </a:ext>
+            </a:extLst>
+          </a:blip>
+          <a:srcRect/>
+          <a:stretch>
+            <a:fillRect/>
+          </a:stretch>
+        </p:blipFill>
+        <p:spPr bwMode="auto">
+          <a:xfrm>
+            <a:off x="3546547" y="213360"/>
+            <a:ext cx="4819247" cy="4409902"/>
+          </a:xfrm>
+          <a:prstGeom prst="rect">
+            <a:avLst/>
+          </a:prstGeom>
+          <a:noFill/>
+          <a:extLst>
+            <a:ext uri="{909E8E84-426E-40DD-AFC4-6F175D3DCCD1}">
+              <a14:hiddenFill xmlns:a14="http://schemas.microsoft.com/office/drawing/2010/main">
+                <a:solidFill>
+                  <a:srgbClr val="FFFFFF"/>
+                </a:solidFill>
+              </a14:hiddenFill>
+            </a:ext>
+          </a:extLst>
+        </p:spPr>
+      </p:pic>
+      <p:sp>
+        <p:nvSpPr>
+          <p:cNvPr id="4" name="TextBox 3">
+            <a:extLst>
+              <a:ext uri="{FF2B5EF4-FFF2-40B4-BE49-F238E27FC236}">
+                <a16:creationId xmlns:a16="http://schemas.microsoft.com/office/drawing/2014/main" id="{E0A9EF8D-7BB0-081A-DCAF-DEA985BF3554}"/>
+              </a:ext>
+            </a:extLst>
+          </p:cNvPr>
+          <p:cNvSpPr txBox="1"/>
+          <p:nvPr/>
+        </p:nvSpPr>
+        <p:spPr>
+          <a:xfrm>
+            <a:off x="3207327" y="4987917"/>
+            <a:ext cx="6255327" cy="369332"/>
+          </a:xfrm>
+          <a:prstGeom prst="rect">
+            <a:avLst/>
+          </a:prstGeom>
+          <a:noFill/>
+        </p:spPr>
+        <p:txBody>
+          <a:bodyPr wrap="square">
+            <a:spAutoFit/>
+          </a:bodyPr>
+          <a:lstStyle/>
+          <a:p>
+            <a:r>
+              <a:rPr lang="en-US" dirty="0"/>
+              <a:t>SLURM – Simple Linux Utility for Resource Management</a:t>
+            </a:r>
+          </a:p>
+        </p:txBody>
+      </p:sp>
+    </p:spTree>
+    <p:extLst>
+      <p:ext uri="{BB962C8B-B14F-4D97-AF65-F5344CB8AC3E}">
+        <p14:creationId xmlns:p14="http://schemas.microsoft.com/office/powerpoint/2010/main" val="2972566723"/>
+      </p:ext>
+    </p:extLst>
+  </p:cSld>
+  <p:clrMapOvr>
+    <a:masterClrMapping/>
+  </p:clrMapOvr>
+</p:sld>
+</file>
+
+<file path=ppt/slides/slide40.xml><?xml version="1.0" encoding="utf-8"?>
 <p:sld xmlns:a="http://schemas.openxmlformats.org/drawingml/2006/main" xmlns:r="http://schemas.openxmlformats.org/officeDocument/2006/relationships" xmlns:p="http://schemas.openxmlformats.org/presentationml/2006/main" show="0">
   <p:cSld>
     <p:spTree>
@@ -25793,7 +26603,7 @@
 </p:sld>
 </file>
 
-<file path=ppt/slides/slide4.xml><?xml version="1.0" encoding="utf-8"?>
+<file path=ppt/slides/slide5.xml><?xml version="1.0" encoding="utf-8"?>
 <p:sld xmlns:a="http://schemas.openxmlformats.org/drawingml/2006/main" xmlns:r="http://schemas.openxmlformats.org/officeDocument/2006/relationships" xmlns:p="http://schemas.openxmlformats.org/presentationml/2006/main">
   <p:cSld>
     <p:spTree>
@@ -26219,7 +27029,7 @@
 </p:sld>
 </file>
 
-<file path=ppt/slides/slide5.xml><?xml version="1.0" encoding="utf-8"?>
+<file path=ppt/slides/slide6.xml><?xml version="1.0" encoding="utf-8"?>
 <p:sld xmlns:a="http://schemas.openxmlformats.org/drawingml/2006/main" xmlns:r="http://schemas.openxmlformats.org/officeDocument/2006/relationships" xmlns:p="http://schemas.openxmlformats.org/presentationml/2006/main">
   <p:cSld>
     <p:spTree>
@@ -26599,7 +27409,7 @@
 </p:sld>
 </file>
 
-<file path=ppt/slides/slide6.xml><?xml version="1.0" encoding="utf-8"?>
+<file path=ppt/slides/slide7.xml><?xml version="1.0" encoding="utf-8"?>
 <p:sld xmlns:a="http://schemas.openxmlformats.org/drawingml/2006/main" xmlns:r="http://schemas.openxmlformats.org/officeDocument/2006/relationships" xmlns:p="http://schemas.openxmlformats.org/presentationml/2006/main">
   <p:cSld>
     <p:spTree>
@@ -27083,7 +27893,7 @@
 </p:sld>
 </file>
 
-<file path=ppt/slides/slide7.xml><?xml version="1.0" encoding="utf-8"?>
+<file path=ppt/slides/slide8.xml><?xml version="1.0" encoding="utf-8"?>
 <p:sld xmlns:a="http://schemas.openxmlformats.org/drawingml/2006/main" xmlns:r="http://schemas.openxmlformats.org/officeDocument/2006/relationships" xmlns:p="http://schemas.openxmlformats.org/presentationml/2006/main">
   <p:cSld>
     <p:spTree>
@@ -27567,7 +28377,7 @@
 </p:sld>
 </file>
 
-<file path=ppt/slides/slide8.xml><?xml version="1.0" encoding="utf-8"?>
+<file path=ppt/slides/slide9.xml><?xml version="1.0" encoding="utf-8"?>
 <p:sld xmlns:a="http://schemas.openxmlformats.org/drawingml/2006/main" xmlns:r="http://schemas.openxmlformats.org/officeDocument/2006/relationships" xmlns:p="http://schemas.openxmlformats.org/presentationml/2006/main">
   <p:cSld>
     <p:spTree>
@@ -28042,498 +28852,6 @@
     <p:extLst>
       <p:ext uri="{BB962C8B-B14F-4D97-AF65-F5344CB8AC3E}">
         <p14:creationId xmlns:p14="http://schemas.microsoft.com/office/powerpoint/2010/main" val="3807998629"/>
-      </p:ext>
-    </p:extLst>
-  </p:cSld>
-  <p:clrMapOvr>
-    <a:masterClrMapping/>
-  </p:clrMapOvr>
-</p:sld>
-</file>
-
-<file path=ppt/slides/slide9.xml><?xml version="1.0" encoding="utf-8"?>
-<p:sld xmlns:a="http://schemas.openxmlformats.org/drawingml/2006/main" xmlns:r="http://schemas.openxmlformats.org/officeDocument/2006/relationships" xmlns:p="http://schemas.openxmlformats.org/presentationml/2006/main">
-  <p:cSld>
-    <p:spTree>
-      <p:nvGrpSpPr>
-        <p:cNvPr id="1" name="">
-          <a:extLst>
-            <a:ext uri="{FF2B5EF4-FFF2-40B4-BE49-F238E27FC236}">
-              <a16:creationId xmlns:a16="http://schemas.microsoft.com/office/drawing/2014/main" id="{848074D2-25CE-7AA7-BBF0-2C11EF753D11}"/>
-            </a:ext>
-          </a:extLst>
-        </p:cNvPr>
-        <p:cNvGrpSpPr/>
-        <p:nvPr/>
-      </p:nvGrpSpPr>
-      <p:grpSpPr>
-        <a:xfrm>
-          <a:off x="0" y="0"/>
-          <a:ext cx="0" cy="0"/>
-          <a:chOff x="0" y="0"/>
-          <a:chExt cx="0" cy="0"/>
-        </a:xfrm>
-      </p:grpSpPr>
-      <p:sp>
-        <p:nvSpPr>
-          <p:cNvPr id="2" name="Title 1">
-            <a:extLst>
-              <a:ext uri="{FF2B5EF4-FFF2-40B4-BE49-F238E27FC236}">
-                <a16:creationId xmlns:a16="http://schemas.microsoft.com/office/drawing/2014/main" id="{DCFB93B0-6835-5C78-E7E2-252E13977148}"/>
-              </a:ext>
-            </a:extLst>
-          </p:cNvPr>
-          <p:cNvSpPr>
-            <a:spLocks noGrp="1"/>
-          </p:cNvSpPr>
-          <p:nvPr>
-            <p:ph type="ctrTitle"/>
-          </p:nvPr>
-        </p:nvSpPr>
-        <p:spPr>
-          <a:xfrm>
-            <a:off x="1524000" y="204143"/>
-            <a:ext cx="9144000" cy="557441"/>
-          </a:xfrm>
-        </p:spPr>
-        <p:txBody>
-          <a:bodyPr>
-            <a:normAutofit fontScale="90000"/>
-          </a:bodyPr>
-          <a:lstStyle/>
-          <a:p>
-            <a:r>
-              <a:rPr lang="en-US" sz="3600" dirty="0"/>
-              <a:t>Every job needs a job submission script:</a:t>
-            </a:r>
-          </a:p>
-        </p:txBody>
-      </p:sp>
-      <p:sp>
-        <p:nvSpPr>
-          <p:cNvPr id="5" name="TextBox 4">
-            <a:extLst>
-              <a:ext uri="{FF2B5EF4-FFF2-40B4-BE49-F238E27FC236}">
-                <a16:creationId xmlns:a16="http://schemas.microsoft.com/office/drawing/2014/main" id="{0FAB5DF2-474C-68E4-24AA-826CDEEDF0EB}"/>
-              </a:ext>
-            </a:extLst>
-          </p:cNvPr>
-          <p:cNvSpPr txBox="1"/>
-          <p:nvPr/>
-        </p:nvSpPr>
-        <p:spPr>
-          <a:xfrm>
-            <a:off x="464652" y="1343888"/>
-            <a:ext cx="6504183" cy="4801314"/>
-          </a:xfrm>
-          <a:prstGeom prst="rect">
-            <a:avLst/>
-          </a:prstGeom>
-          <a:solidFill>
-            <a:schemeClr val="accent1">
-              <a:alpha val="16000"/>
-            </a:schemeClr>
-          </a:solidFill>
-          <a:ln>
-            <a:solidFill>
-              <a:schemeClr val="accent1"/>
-            </a:solidFill>
-          </a:ln>
-        </p:spPr>
-        <p:txBody>
-          <a:bodyPr wrap="square">
-            <a:spAutoFit/>
-          </a:bodyPr>
-          <a:lstStyle/>
-          <a:p>
-            <a:r>
-              <a:rPr lang="en-US" dirty="0"/>
-              <a:t>#!/bin/bash</a:t>
-            </a:r>
-          </a:p>
-          <a:p>
-            <a:endParaRPr lang="en-US" dirty="0"/>
-          </a:p>
-          <a:p>
-            <a:r>
-              <a:rPr lang="en-US" dirty="0"/>
-              <a:t>#SBATCH --partition=</a:t>
-            </a:r>
-            <a:r>
-              <a:rPr lang="en-US" dirty="0" err="1"/>
-              <a:t>defq</a:t>
-            </a:r>
-            <a:endParaRPr lang="en-US" dirty="0"/>
-          </a:p>
-          <a:p>
-            <a:r>
-              <a:rPr lang="en-US" dirty="0"/>
-              <a:t>#SBATCH --nodes=1</a:t>
-            </a:r>
-          </a:p>
-          <a:p>
-            <a:r>
-              <a:rPr lang="en-US" dirty="0"/>
-              <a:t>#SBATCH --</a:t>
-            </a:r>
-            <a:r>
-              <a:rPr lang="en-US" dirty="0" err="1"/>
-              <a:t>ntasks</a:t>
-            </a:r>
-            <a:r>
-              <a:rPr lang="en-US" dirty="0"/>
-              <a:t>=1</a:t>
-            </a:r>
-          </a:p>
-          <a:p>
-            <a:r>
-              <a:rPr lang="en-US" dirty="0"/>
-              <a:t>#SBATCH --</a:t>
-            </a:r>
-            <a:r>
-              <a:rPr lang="en-US" dirty="0" err="1"/>
-              <a:t>cpus</a:t>
-            </a:r>
-            <a:r>
-              <a:rPr lang="en-US" dirty="0"/>
-              <a:t>-per-task=8</a:t>
-            </a:r>
-          </a:p>
-          <a:p>
-            <a:r>
-              <a:rPr lang="en-US" dirty="0"/>
-              <a:t>#SBATCH --mem=5g</a:t>
-            </a:r>
-          </a:p>
-          <a:p>
-            <a:r>
-              <a:rPr lang="en-US" dirty="0"/>
-              <a:t>#SBATCH --time=00:10:00</a:t>
-            </a:r>
-          </a:p>
-          <a:p>
-            <a:r>
-              <a:rPr lang="en-US" dirty="0"/>
-              <a:t>#SBATCH --job-name=</a:t>
-            </a:r>
-            <a:r>
-              <a:rPr lang="en-US" dirty="0" err="1"/>
-              <a:t>my_job</a:t>
-            </a:r>
-            <a:endParaRPr lang="en-US" dirty="0"/>
-          </a:p>
-          <a:p>
-            <a:r>
-              <a:rPr lang="en-US" dirty="0"/>
-              <a:t>#SBATCH --output=/gpfs01/home/</a:t>
-            </a:r>
-            <a:r>
-              <a:rPr lang="en-US" dirty="0" err="1">
-                <a:solidFill>
-                  <a:schemeClr val="accent6">
-                    <a:lumMod val="75000"/>
-                  </a:schemeClr>
-                </a:solidFill>
-              </a:rPr>
-              <a:t>mbzlld</a:t>
-            </a:r>
-            <a:r>
-              <a:rPr lang="en-US" dirty="0"/>
-              <a:t>/</a:t>
-            </a:r>
-            <a:r>
-              <a:rPr lang="en-US" dirty="0" err="1"/>
-              <a:t>slurm</a:t>
-            </a:r>
-            <a:r>
-              <a:rPr lang="en-US" dirty="0"/>
-              <a:t>-%x-%</a:t>
-            </a:r>
-            <a:r>
-              <a:rPr lang="en-US" dirty="0" err="1"/>
-              <a:t>j.out</a:t>
-            </a:r>
-            <a:endParaRPr lang="en-US" dirty="0"/>
-          </a:p>
-          <a:p>
-            <a:r>
-              <a:rPr lang="en-US" dirty="0"/>
-              <a:t>#SBATCH --error=/gpfs01/home/</a:t>
-            </a:r>
-            <a:r>
-              <a:rPr lang="en-US" dirty="0" err="1">
-                <a:solidFill>
-                  <a:schemeClr val="accent6">
-                    <a:lumMod val="75000"/>
-                  </a:schemeClr>
-                </a:solidFill>
-              </a:rPr>
-              <a:t>mbzlld</a:t>
-            </a:r>
-            <a:r>
-              <a:rPr lang="en-US" dirty="0"/>
-              <a:t>/</a:t>
-            </a:r>
-            <a:r>
-              <a:rPr lang="en-US" dirty="0" err="1"/>
-              <a:t>slurm</a:t>
-            </a:r>
-            <a:r>
-              <a:rPr lang="en-US" dirty="0"/>
-              <a:t>-%x-%</a:t>
-            </a:r>
-            <a:r>
-              <a:rPr lang="en-US" dirty="0" err="1"/>
-              <a:t>j.err</a:t>
-            </a:r>
-            <a:endParaRPr lang="en-US" dirty="0"/>
-          </a:p>
-          <a:p>
-            <a:r>
-              <a:rPr lang="en-US" dirty="0"/>
-              <a:t>#SBATCH --mail-type=ALL</a:t>
-            </a:r>
-          </a:p>
-          <a:p>
-            <a:r>
-              <a:rPr lang="en-US" dirty="0"/>
-              <a:t>#SBATCH --mail-user=</a:t>
-            </a:r>
-            <a:r>
-              <a:rPr lang="en-US" dirty="0" err="1">
-                <a:solidFill>
-                  <a:schemeClr val="accent6">
-                    <a:lumMod val="75000"/>
-                  </a:schemeClr>
-                </a:solidFill>
-              </a:rPr>
-              <a:t>mbzlld</a:t>
-            </a:r>
-            <a:r>
-              <a:rPr lang="en-US" dirty="0" err="1"/>
-              <a:t>@exmail.nottingham.ac.uk</a:t>
-            </a:r>
-            <a:endParaRPr lang="en-US" dirty="0"/>
-          </a:p>
-          <a:p>
-            <a:endParaRPr lang="en-US" dirty="0"/>
-          </a:p>
-          <a:p>
-            <a:r>
-              <a:rPr lang="en-US" dirty="0"/>
-              <a:t># Write out a test file to check our job ran</a:t>
-            </a:r>
-          </a:p>
-          <a:p>
-            <a:r>
-              <a:rPr lang="en-US" dirty="0"/>
-              <a:t>echo “hello world” &gt; ~/</a:t>
-            </a:r>
-            <a:r>
-              <a:rPr lang="en-US" dirty="0" err="1"/>
-              <a:t>our_test_output.txt</a:t>
-            </a:r>
-            <a:endParaRPr lang="en-US" dirty="0"/>
-          </a:p>
-          <a:p>
-            <a:endParaRPr lang="en-US" dirty="0"/>
-          </a:p>
-        </p:txBody>
-      </p:sp>
-      <p:sp>
-        <p:nvSpPr>
-          <p:cNvPr id="7" name="TextBox 6">
-            <a:extLst>
-              <a:ext uri="{FF2B5EF4-FFF2-40B4-BE49-F238E27FC236}">
-                <a16:creationId xmlns:a16="http://schemas.microsoft.com/office/drawing/2014/main" id="{8675C216-BDE8-1459-37E9-65D06D5F2075}"/>
-              </a:ext>
-            </a:extLst>
-          </p:cNvPr>
-          <p:cNvSpPr txBox="1"/>
-          <p:nvPr/>
-        </p:nvSpPr>
-        <p:spPr>
-          <a:xfrm>
-            <a:off x="430009" y="923142"/>
-            <a:ext cx="3286734" cy="369332"/>
-          </a:xfrm>
-          <a:prstGeom prst="rect">
-            <a:avLst/>
-          </a:prstGeom>
-          <a:noFill/>
-        </p:spPr>
-        <p:txBody>
-          <a:bodyPr wrap="none" rtlCol="0">
-            <a:spAutoFit/>
-          </a:bodyPr>
-          <a:lstStyle/>
-          <a:p>
-            <a:r>
-              <a:rPr lang="en-US" dirty="0"/>
-              <a:t>Example job submission script:</a:t>
-            </a:r>
-          </a:p>
-        </p:txBody>
-      </p:sp>
-      <p:sp>
-        <p:nvSpPr>
-          <p:cNvPr id="22" name="TextBox 21">
-            <a:extLst>
-              <a:ext uri="{FF2B5EF4-FFF2-40B4-BE49-F238E27FC236}">
-                <a16:creationId xmlns:a16="http://schemas.microsoft.com/office/drawing/2014/main" id="{C2EBE4C2-0FA6-720C-97E4-BB6D97794B0C}"/>
-              </a:ext>
-            </a:extLst>
-          </p:cNvPr>
-          <p:cNvSpPr txBox="1"/>
-          <p:nvPr/>
-        </p:nvSpPr>
-        <p:spPr>
-          <a:xfrm>
-            <a:off x="430009" y="6418830"/>
-            <a:ext cx="11568027" cy="338554"/>
-          </a:xfrm>
-          <a:prstGeom prst="rect">
-            <a:avLst/>
-          </a:prstGeom>
-          <a:noFill/>
-        </p:spPr>
-        <p:txBody>
-          <a:bodyPr wrap="square" rtlCol="0">
-            <a:spAutoFit/>
-          </a:bodyPr>
-          <a:lstStyle/>
-          <a:p>
-            <a:r>
-              <a:rPr lang="en-US" sz="1600" dirty="0"/>
-              <a:t>NOTE: My username is </a:t>
-            </a:r>
-            <a:r>
-              <a:rPr lang="en-US" sz="1600" dirty="0" err="1">
-                <a:solidFill>
-                  <a:schemeClr val="accent6">
-                    <a:lumMod val="75000"/>
-                  </a:schemeClr>
-                </a:solidFill>
-              </a:rPr>
-              <a:t>mbzlld</a:t>
-            </a:r>
-            <a:r>
-              <a:rPr lang="en-US" sz="1600" dirty="0"/>
-              <a:t> – where you see this in the scripts you will need to replace it with your own university username</a:t>
-            </a:r>
-          </a:p>
-        </p:txBody>
-      </p:sp>
-      <p:sp>
-        <p:nvSpPr>
-          <p:cNvPr id="3" name="Rectangle 2">
-            <a:extLst>
-              <a:ext uri="{FF2B5EF4-FFF2-40B4-BE49-F238E27FC236}">
-                <a16:creationId xmlns:a16="http://schemas.microsoft.com/office/drawing/2014/main" id="{A284D37C-D2D3-602F-B6BE-9CD91361225E}"/>
-              </a:ext>
-            </a:extLst>
-          </p:cNvPr>
-          <p:cNvSpPr/>
-          <p:nvPr/>
-        </p:nvSpPr>
-        <p:spPr>
-          <a:xfrm>
-            <a:off x="249382" y="2452259"/>
-            <a:ext cx="3467361" cy="332509"/>
-          </a:xfrm>
-          <a:prstGeom prst="rect">
-            <a:avLst/>
-          </a:prstGeom>
-          <a:solidFill>
-            <a:schemeClr val="accent1">
-              <a:alpha val="42761"/>
-            </a:schemeClr>
-          </a:solidFill>
-        </p:spPr>
-        <p:style>
-          <a:lnRef idx="2">
-            <a:schemeClr val="accent1">
-              <a:shade val="15000"/>
-            </a:schemeClr>
-          </a:lnRef>
-          <a:fillRef idx="1">
-            <a:schemeClr val="accent1"/>
-          </a:fillRef>
-          <a:effectRef idx="0">
-            <a:schemeClr val="accent1"/>
-          </a:effectRef>
-          <a:fontRef idx="minor">
-            <a:schemeClr val="lt1"/>
-          </a:fontRef>
-        </p:style>
-        <p:txBody>
-          <a:bodyPr rtlCol="0" anchor="ctr"/>
-          <a:lstStyle/>
-          <a:p>
-            <a:pPr algn="ctr"/>
-            <a:endParaRPr lang="en-US"/>
-          </a:p>
-        </p:txBody>
-      </p:sp>
-      <p:sp>
-        <p:nvSpPr>
-          <p:cNvPr id="4" name="TextBox 3">
-            <a:extLst>
-              <a:ext uri="{FF2B5EF4-FFF2-40B4-BE49-F238E27FC236}">
-                <a16:creationId xmlns:a16="http://schemas.microsoft.com/office/drawing/2014/main" id="{60ACBA33-0475-1859-940C-9B1ACA5219D4}"/>
-              </a:ext>
-            </a:extLst>
-          </p:cNvPr>
-          <p:cNvSpPr txBox="1"/>
-          <p:nvPr/>
-        </p:nvSpPr>
-        <p:spPr>
-          <a:xfrm>
-            <a:off x="7561376" y="1898073"/>
-            <a:ext cx="3605388" cy="2031325"/>
-          </a:xfrm>
-          <a:prstGeom prst="rect">
-            <a:avLst/>
-          </a:prstGeom>
-          <a:noFill/>
-        </p:spPr>
-        <p:txBody>
-          <a:bodyPr wrap="square" rtlCol="0">
-            <a:spAutoFit/>
-          </a:bodyPr>
-          <a:lstStyle/>
-          <a:p>
-            <a:r>
-              <a:rPr lang="en-US" dirty="0"/>
-              <a:t>--</a:t>
-            </a:r>
-            <a:r>
-              <a:rPr lang="en-US" dirty="0" err="1"/>
-              <a:t>ntasks</a:t>
-            </a:r>
-            <a:r>
-              <a:rPr lang="en-US" dirty="0"/>
-              <a:t>= </a:t>
-            </a:r>
-          </a:p>
-          <a:p>
-            <a:endParaRPr lang="en-US" dirty="0"/>
-          </a:p>
-          <a:p>
-            <a:r>
-              <a:rPr lang="en-US" dirty="0"/>
-              <a:t>Select how many separate tasks you want your job to be split across (for most jobs this will also be 1)</a:t>
-            </a:r>
-          </a:p>
-          <a:p>
-            <a:endParaRPr lang="en-US" dirty="0"/>
-          </a:p>
-        </p:txBody>
-      </p:sp>
-    </p:spTree>
-    <p:extLst>
-      <p:ext uri="{BB962C8B-B14F-4D97-AF65-F5344CB8AC3E}">
-        <p14:creationId xmlns:p14="http://schemas.microsoft.com/office/powerpoint/2010/main" val="458446712"/>
       </p:ext>
     </p:extLst>
   </p:cSld>

</xml_diff>